<commit_message>
feat(ppt-saz): v3.2 continuous infinite looping motion engine for background particles, orbital rings, and dials
</commit_message>
<xml_diff>
--- a/examples/sample_output.pptx
+++ b/examples/sample_output.pptx
@@ -3029,7 +3029,7 @@
   </p:clrMapOvr>
   <mc:AlternateContent xmlns:mc="http://schemas.openxmlformats.org/markup-compatibility/2006">
     <mc:Choice xmlns:p159="http://schemas.microsoft.com/office/powerpoint/2015/09/main" Requires="p159">
-      <p:transition xmlns:p14="http://schemas.microsoft.com/office/powerpoint/2010/main" p14:dur="400">
+      <p:transition xmlns:p14="http://schemas.microsoft.com/office/powerpoint/2010/main" p14:dur="500">
         <p159:morph option="byObject"/>
       </p:transition>
     </mc:Choice>
@@ -3088,7 +3088,7 @@
                                     </p:set>
                                     <p:animEffect transition="in" filter="fade">
                                       <p:cBhvr>
-                                        <p:cTn id="7" dur="400"/>
+                                        <p:cTn id="7" dur="500"/>
                                         <p:tgtEl>
                                           <p:spTgt spid="5"/>
                                         </p:tgtEl>
@@ -3103,110 +3103,26 @@
                         <p:par>
                           <p:cTn id="8" fill="hold">
                             <p:stCondLst>
-                              <p:cond delay="400"/>
+                              <p:cond delay="0"/>
                             </p:stCondLst>
                             <p:childTnLst>
                               <p:par>
-                                <p:cTn xmlns:p="http://schemas.openxmlformats.org/presentationml/2006/main" id="9" presetID="49" presetClass="entr" presetSubtype="0" decel="100000" fill="hold" grpId="0" nodeType="afterEffect">
+                                <p:cTn xmlns:p="http://schemas.openxmlformats.org/presentationml/2006/main" id="9" presetID="8" presetClass="emph" presetSubtype="0" fill="hold" grpId="0" nodeType="withEffect" repeatCount="999000">
                                   <p:stCondLst>
-                                    <p:cond delay="350"/>
+                                    <p:cond delay="0"/>
                                   </p:stCondLst>
                                   <p:childTnLst>
-                                    <p:set>
+                                    <p:animRot by="21600000">
                                       <p:cBhvr>
-                                        <p:cTn id="10" dur="1" fill="hold">
-                                          <p:stCondLst>
-                                            <p:cond delay="0"/>
-                                          </p:stCondLst>
-                                        </p:cTn>
+                                        <p:cTn id="10" dur="8000" fill="hold"/>
                                         <p:tgtEl>
                                           <p:spTgt spid="17"/>
                                         </p:tgtEl>
                                         <p:attrNameLst>
-                                          <p:attrName>style.visibility</p:attrName>
+                                          <p:attrName>r</p:attrName>
                                         </p:attrNameLst>
                                       </p:cBhvr>
-                                      <p:to>
-                                        <p:strVal val="visible"/>
-                                      </p:to>
-                                    </p:set>
-                                    <p:anim calcmode="lin" valueType="num">
-                                      <p:cBhvr>
-                                        <p:cTn id="11" dur="400" fill="hold"/>
-                                        <p:tgtEl>
-                                          <p:spTgt spid="17"/>
-                                        </p:tgtEl>
-                                        <p:attrNameLst>
-                                          <p:attrName>ppt_w</p:attrName>
-                                        </p:attrNameLst>
-                                      </p:cBhvr>
-                                      <p:tavLst>
-                                        <p:tav tm="0">
-                                          <p:val>
-                                            <p:fltVal val="0"/>
-                                          </p:val>
-                                        </p:tav>
-                                        <p:tav tm="100000">
-                                          <p:val>
-                                            <p:strVal val="#ppt_w"/>
-                                          </p:val>
-                                        </p:tav>
-                                      </p:tavLst>
-                                    </p:anim>
-                                    <p:anim calcmode="lin" valueType="num">
-                                      <p:cBhvr>
-                                        <p:cTn id="12" dur="400" fill="hold"/>
-                                        <p:tgtEl>
-                                          <p:spTgt spid="17"/>
-                                        </p:tgtEl>
-                                        <p:attrNameLst>
-                                          <p:attrName>ppt_h</p:attrName>
-                                        </p:attrNameLst>
-                                      </p:cBhvr>
-                                      <p:tavLst>
-                                        <p:tav tm="0">
-                                          <p:val>
-                                            <p:fltVal val="0"/>
-                                          </p:val>
-                                        </p:tav>
-                                        <p:tav tm="100000">
-                                          <p:val>
-                                            <p:strVal val="#ppt_h"/>
-                                          </p:val>
-                                        </p:tav>
-                                      </p:tavLst>
-                                    </p:anim>
-                                    <p:anim calcmode="lin" valueType="num">
-                                      <p:cBhvr>
-                                        <p:cTn id="13" dur="400" fill="hold"/>
-                                        <p:tgtEl>
-                                          <p:spTgt spid="17"/>
-                                        </p:tgtEl>
-                                        <p:attrNameLst>
-                                          <p:attrName>style.rotation</p:attrName>
-                                        </p:attrNameLst>
-                                      </p:cBhvr>
-                                      <p:tavLst>
-                                        <p:tav tm="0">
-                                          <p:val>
-                                            <p:fltVal val="360"/>
-                                          </p:val>
-                                        </p:tav>
-                                        <p:tav tm="100000">
-                                          <p:val>
-                                            <p:fltVal val="0"/>
-                                          </p:val>
-                                        </p:tav>
-                                      </p:tavLst>
-                                    </p:anim>
-                                    <p:animEffect transition="in" filter="fade">
-                                      <p:cBhvr>
-                                        <p:cTn id="14" dur="400"/>
-                                        <p:tgtEl>
-                                          <p:spTgt spid="17"/>
-                                        </p:tgtEl>
-                                      </p:cBhvr>
-                                    </p:animEffect>
+                                    </p:animRot>
                                   </p:childTnLst>
                                 </p:cTn>
                               </p:par>
@@ -3214,112 +3130,28 @@
                           </p:cTn>
                         </p:par>
                         <p:par>
-                          <p:cTn id="15" fill="hold">
+                          <p:cTn id="11" fill="hold">
                             <p:stCondLst>
-                              <p:cond delay="1150"/>
+                              <p:cond delay="0"/>
                             </p:stCondLst>
                             <p:childTnLst>
                               <p:par>
-                                <p:cTn xmlns:p="http://schemas.openxmlformats.org/presentationml/2006/main" id="16" presetID="49" presetClass="entr" presetSubtype="0" decel="100000" fill="hold" grpId="0" nodeType="afterEffect">
+                                <p:cTn xmlns:p="http://schemas.openxmlformats.org/presentationml/2006/main" id="12" presetID="8" presetClass="emph" presetSubtype="0" fill="hold" grpId="0" nodeType="withEffect" repeatCount="999000">
                                   <p:stCondLst>
-                                    <p:cond delay="350"/>
+                                    <p:cond delay="0"/>
                                   </p:stCondLst>
                                   <p:childTnLst>
-                                    <p:set>
+                                    <p:animRot by="21600000">
                                       <p:cBhvr>
-                                        <p:cTn id="17" dur="1" fill="hold">
-                                          <p:stCondLst>
-                                            <p:cond delay="0"/>
-                                          </p:stCondLst>
-                                        </p:cTn>
+                                        <p:cTn id="13" dur="12000" fill="hold"/>
                                         <p:tgtEl>
                                           <p:spTgt spid="34"/>
                                         </p:tgtEl>
                                         <p:attrNameLst>
-                                          <p:attrName>style.visibility</p:attrName>
+                                          <p:attrName>r</p:attrName>
                                         </p:attrNameLst>
                                       </p:cBhvr>
-                                      <p:to>
-                                        <p:strVal val="visible"/>
-                                      </p:to>
-                                    </p:set>
-                                    <p:anim calcmode="lin" valueType="num">
-                                      <p:cBhvr>
-                                        <p:cTn id="18" dur="400" fill="hold"/>
-                                        <p:tgtEl>
-                                          <p:spTgt spid="34"/>
-                                        </p:tgtEl>
-                                        <p:attrNameLst>
-                                          <p:attrName>ppt_w</p:attrName>
-                                        </p:attrNameLst>
-                                      </p:cBhvr>
-                                      <p:tavLst>
-                                        <p:tav tm="0">
-                                          <p:val>
-                                            <p:fltVal val="0"/>
-                                          </p:val>
-                                        </p:tav>
-                                        <p:tav tm="100000">
-                                          <p:val>
-                                            <p:strVal val="#ppt_w"/>
-                                          </p:val>
-                                        </p:tav>
-                                      </p:tavLst>
-                                    </p:anim>
-                                    <p:anim calcmode="lin" valueType="num">
-                                      <p:cBhvr>
-                                        <p:cTn id="19" dur="400" fill="hold"/>
-                                        <p:tgtEl>
-                                          <p:spTgt spid="34"/>
-                                        </p:tgtEl>
-                                        <p:attrNameLst>
-                                          <p:attrName>ppt_h</p:attrName>
-                                        </p:attrNameLst>
-                                      </p:cBhvr>
-                                      <p:tavLst>
-                                        <p:tav tm="0">
-                                          <p:val>
-                                            <p:fltVal val="0"/>
-                                          </p:val>
-                                        </p:tav>
-                                        <p:tav tm="100000">
-                                          <p:val>
-                                            <p:strVal val="#ppt_h"/>
-                                          </p:val>
-                                        </p:tav>
-                                      </p:tavLst>
-                                    </p:anim>
-                                    <p:anim calcmode="lin" valueType="num">
-                                      <p:cBhvr>
-                                        <p:cTn id="20" dur="400" fill="hold"/>
-                                        <p:tgtEl>
-                                          <p:spTgt spid="34"/>
-                                        </p:tgtEl>
-                                        <p:attrNameLst>
-                                          <p:attrName>style.rotation</p:attrName>
-                                        </p:attrNameLst>
-                                      </p:cBhvr>
-                                      <p:tavLst>
-                                        <p:tav tm="0">
-                                          <p:val>
-                                            <p:fltVal val="360"/>
-                                          </p:val>
-                                        </p:tav>
-                                        <p:tav tm="100000">
-                                          <p:val>
-                                            <p:fltVal val="0"/>
-                                          </p:val>
-                                        </p:tav>
-                                      </p:tavLst>
-                                    </p:anim>
-                                    <p:animEffect transition="in" filter="fade">
-                                      <p:cBhvr>
-                                        <p:cTn id="21" dur="400"/>
-                                        <p:tgtEl>
-                                          <p:spTgt spid="34"/>
-                                        </p:tgtEl>
-                                      </p:cBhvr>
-                                    </p:animEffect>
+                                    </p:animRot>
                                   </p:childTnLst>
                                 </p:cTn>
                               </p:par>
@@ -3327,20 +3159,20 @@
                           </p:cTn>
                         </p:par>
                         <p:par>
-                          <p:cTn id="22" fill="hold">
+                          <p:cTn id="14" fill="hold">
                             <p:stCondLst>
-                              <p:cond delay="1900"/>
+                              <p:cond delay="0"/>
                             </p:stCondLst>
                             <p:childTnLst>
                               <p:par>
-                                <p:cTn xmlns:p="http://schemas.openxmlformats.org/presentationml/2006/main" id="23" presetID="23" presetClass="entr" presetSubtype="16" fill="hold" grpId="0" nodeType="afterEffect">
+                                <p:cTn xmlns:p="http://schemas.openxmlformats.org/presentationml/2006/main" id="15" presetID="23" presetClass="entr" presetSubtype="16" fill="hold" grpId="0" nodeType="afterEffect">
                                   <p:stCondLst>
                                     <p:cond delay="350"/>
                                   </p:stCondLst>
                                   <p:childTnLst>
                                     <p:set>
                                       <p:cBhvr>
-                                        <p:cTn id="24" dur="1" fill="hold">
+                                        <p:cTn id="16" dur="1" fill="hold">
                                           <p:stCondLst>
                                             <p:cond delay="0"/>
                                           </p:stCondLst>
@@ -3358,7 +3190,7 @@
                                     </p:set>
                                     <p:anim calcmode="lin" valueType="num">
                                       <p:cBhvr>
-                                        <p:cTn id="25" dur="400" fill="hold"/>
+                                        <p:cTn id="17" dur="500" fill="hold"/>
                                         <p:tgtEl>
                                           <p:spTgt spid="38"/>
                                         </p:tgtEl>
@@ -3381,7 +3213,7 @@
                                     </p:anim>
                                     <p:anim calcmode="lin" valueType="num">
                                       <p:cBhvr>
-                                        <p:cTn id="26" dur="400" fill="hold"/>
+                                        <p:cTn id="18" dur="500" fill="hold"/>
                                         <p:tgtEl>
                                           <p:spTgt spid="38"/>
                                         </p:tgtEl>
@@ -3409,20 +3241,20 @@
                           </p:cTn>
                         </p:par>
                         <p:par>
-                          <p:cTn id="27" fill="hold">
+                          <p:cTn id="19" fill="hold">
                             <p:stCondLst>
-                              <p:cond delay="2650"/>
+                              <p:cond delay="850"/>
                             </p:stCondLst>
                             <p:childTnLst>
                               <p:par>
-                                <p:cTn xmlns:p="http://schemas.openxmlformats.org/presentationml/2006/main" id="28" presetID="10" presetClass="entr" presetSubtype="0" fill="hold" grpId="0" nodeType="afterEffect">
+                                <p:cTn xmlns:p="http://schemas.openxmlformats.org/presentationml/2006/main" id="20" presetID="10" presetClass="entr" presetSubtype="0" fill="hold" grpId="0" nodeType="afterEffect">
                                   <p:stCondLst>
                                     <p:cond delay="350"/>
                                   </p:stCondLst>
                                   <p:childTnLst>
                                     <p:set>
                                       <p:cBhvr>
-                                        <p:cTn id="29" dur="1" fill="hold">
+                                        <p:cTn id="21" dur="1" fill="hold">
                                           <p:stCondLst>
                                             <p:cond delay="0"/>
                                           </p:stCondLst>
@@ -3440,7 +3272,7 @@
                                     </p:set>
                                     <p:animEffect transition="in" filter="fade">
                                       <p:cBhvr>
-                                        <p:cTn id="30" dur="400"/>
+                                        <p:cTn id="22" dur="500"/>
                                         <p:tgtEl>
                                           <p:spTgt spid="41"/>
                                         </p:tgtEl>
@@ -3453,20 +3285,20 @@
                           </p:cTn>
                         </p:par>
                         <p:par>
-                          <p:cTn id="31" fill="hold">
+                          <p:cTn id="23" fill="hold">
                             <p:stCondLst>
-                              <p:cond delay="3400"/>
+                              <p:cond delay="1700"/>
                             </p:stCondLst>
                             <p:childTnLst>
                               <p:par>
-                                <p:cTn xmlns:p="http://schemas.openxmlformats.org/presentationml/2006/main" id="32" presetID="49" presetClass="entr" presetSubtype="0" decel="100000" fill="hold" grpId="0" nodeType="afterEffect">
+                                <p:cTn xmlns:p="http://schemas.openxmlformats.org/presentationml/2006/main" id="24" presetID="49" presetClass="entr" presetSubtype="0" decel="100000" fill="hold" grpId="0" nodeType="afterEffect">
                                   <p:stCondLst>
                                     <p:cond delay="350"/>
                                   </p:stCondLst>
                                   <p:childTnLst>
                                     <p:set>
                                       <p:cBhvr>
-                                        <p:cTn id="33" dur="1" fill="hold">
+                                        <p:cTn id="25" dur="1" fill="hold">
                                           <p:stCondLst>
                                             <p:cond delay="0"/>
                                           </p:stCondLst>
@@ -3484,7 +3316,7 @@
                                     </p:set>
                                     <p:anim calcmode="lin" valueType="num">
                                       <p:cBhvr>
-                                        <p:cTn id="34" dur="400" fill="hold"/>
+                                        <p:cTn id="26" dur="500" fill="hold"/>
                                         <p:tgtEl>
                                           <p:spTgt spid="44"/>
                                         </p:tgtEl>
@@ -3507,7 +3339,7 @@
                                     </p:anim>
                                     <p:anim calcmode="lin" valueType="num">
                                       <p:cBhvr>
-                                        <p:cTn id="35" dur="400" fill="hold"/>
+                                        <p:cTn id="27" dur="500" fill="hold"/>
                                         <p:tgtEl>
                                           <p:spTgt spid="44"/>
                                         </p:tgtEl>
@@ -3530,7 +3362,7 @@
                                     </p:anim>
                                     <p:anim calcmode="lin" valueType="num">
                                       <p:cBhvr>
-                                        <p:cTn id="36" dur="400" fill="hold"/>
+                                        <p:cTn id="28" dur="500" fill="hold"/>
                                         <p:tgtEl>
                                           <p:spTgt spid="44"/>
                                         </p:tgtEl>
@@ -3553,7 +3385,7 @@
                                     </p:anim>
                                     <p:animEffect transition="in" filter="fade">
                                       <p:cBhvr>
-                                        <p:cTn id="37" dur="400"/>
+                                        <p:cTn id="29" dur="500"/>
                                         <p:tgtEl>
                                           <p:spTgt spid="44"/>
                                         </p:tgtEl>
@@ -3566,20 +3398,20 @@
                           </p:cTn>
                         </p:par>
                         <p:par>
-                          <p:cTn id="38" fill="hold">
+                          <p:cTn id="30" fill="hold">
                             <p:stCondLst>
-                              <p:cond delay="4150"/>
+                              <p:cond delay="2550"/>
                             </p:stCondLst>
                             <p:childTnLst>
                               <p:par>
-                                <p:cTn xmlns:p="http://schemas.openxmlformats.org/presentationml/2006/main" id="39" presetID="2" presetClass="entr" presetSubtype="4" fill="hold" grpId="0" nodeType="afterEffect">
+                                <p:cTn xmlns:p="http://schemas.openxmlformats.org/presentationml/2006/main" id="31" presetID="2" presetClass="entr" presetSubtype="4" fill="hold" grpId="0" nodeType="afterEffect">
                                   <p:stCondLst>
                                     <p:cond delay="350"/>
                                   </p:stCondLst>
                                   <p:childTnLst>
                                     <p:set>
                                       <p:cBhvr>
-                                        <p:cTn id="40" dur="1" fill="hold">
+                                        <p:cTn id="32" dur="1" fill="hold">
                                           <p:stCondLst>
                                             <p:cond delay="0"/>
                                           </p:stCondLst>
@@ -3597,7 +3429,7 @@
                                     </p:set>
                                     <p:anim calcmode="lin" valueType="num">
                                       <p:cBhvr additive="base">
-                                        <p:cTn id="41" dur="400" fill="hold"/>
+                                        <p:cTn id="33" dur="500" fill="hold"/>
                                         <p:tgtEl>
                                           <p:spTgt spid="50"/>
                                         </p:tgtEl>
@@ -3620,7 +3452,7 @@
                                     </p:anim>
                                     <p:anim calcmode="lin" valueType="num">
                                       <p:cBhvr additive="base">
-                                        <p:cTn id="42" dur="400" fill="hold"/>
+                                        <p:cTn id="34" dur="500" fill="hold"/>
                                         <p:tgtEl>
                                           <p:spTgt spid="50"/>
                                         </p:tgtEl>
@@ -3648,43 +3480,28 @@
                           </p:cTn>
                         </p:par>
                         <p:par>
-                          <p:cTn id="43" fill="hold">
+                          <p:cTn id="35" fill="hold">
                             <p:stCondLst>
-                              <p:cond delay="4900"/>
+                              <p:cond delay="2900"/>
                             </p:stCondLst>
                             <p:childTnLst>
                               <p:par>
-                                <p:cTn xmlns:p="http://schemas.openxmlformats.org/presentationml/2006/main" id="44" presetID="9" presetClass="entr" presetSubtype="0" fill="hold" grpId="0" nodeType="afterEffect">
+                                <p:cTn xmlns:p="http://schemas.openxmlformats.org/presentationml/2006/main" id="36" presetID="8" presetClass="emph" presetSubtype="0" fill="hold" grpId="0" nodeType="withEffect" repeatCount="999000">
                                   <p:stCondLst>
-                                    <p:cond delay="350"/>
+                                    <p:cond delay="0"/>
                                   </p:stCondLst>
                                   <p:childTnLst>
-                                    <p:set>
+                                    <p:animRot by="21600000">
                                       <p:cBhvr>
-                                        <p:cTn id="45" dur="1" fill="hold">
-                                          <p:stCondLst>
-                                            <p:cond delay="0"/>
-                                          </p:stCondLst>
-                                        </p:cTn>
+                                        <p:cTn id="37" dur="8000" fill="hold"/>
                                         <p:tgtEl>
                                           <p:spTgt spid="55"/>
                                         </p:tgtEl>
                                         <p:attrNameLst>
-                                          <p:attrName>style.visibility</p:attrName>
+                                          <p:attrName>r</p:attrName>
                                         </p:attrNameLst>
                                       </p:cBhvr>
-                                      <p:to>
-                                        <p:strVal val="visible"/>
-                                      </p:to>
-                                    </p:set>
-                                    <p:animEffect transition="in" filter="dissolve">
-                                      <p:cBhvr>
-                                        <p:cTn id="46" dur="400"/>
-                                        <p:tgtEl>
-                                          <p:spTgt spid="55"/>
-                                        </p:tgtEl>
-                                      </p:cBhvr>
-                                    </p:animEffect>
+                                    </p:animRot>
                                   </p:childTnLst>
                                 </p:cTn>
                               </p:par>
@@ -3692,20 +3509,20 @@
                           </p:cTn>
                         </p:par>
                         <p:par>
-                          <p:cTn id="47" fill="hold">
+                          <p:cTn id="38" fill="hold">
                             <p:stCondLst>
-                              <p:cond delay="5650"/>
+                              <p:cond delay="2900"/>
                             </p:stCondLst>
                             <p:childTnLst>
                               <p:par>
-                                <p:cTn xmlns:p="http://schemas.openxmlformats.org/presentationml/2006/main" id="48" presetID="6" presetClass="entr" presetSubtype="16" fill="hold" grpId="0" nodeType="afterEffect">
+                                <p:cTn xmlns:p="http://schemas.openxmlformats.org/presentationml/2006/main" id="39" presetID="6" presetClass="entr" presetSubtype="16" fill="hold" grpId="0" nodeType="afterEffect">
                                   <p:stCondLst>
                                     <p:cond delay="350"/>
                                   </p:stCondLst>
                                   <p:childTnLst>
                                     <p:set>
                                       <p:cBhvr>
-                                        <p:cTn id="49" dur="1" fill="hold">
+                                        <p:cTn id="40" dur="1" fill="hold">
                                           <p:stCondLst>
                                             <p:cond delay="0"/>
                                           </p:stCondLst>
@@ -3723,7 +3540,7 @@
                                     </p:set>
                                     <p:animEffect transition="in" filter="circle(in)">
                                       <p:cBhvr>
-                                        <p:cTn id="50" dur="400"/>
+                                        <p:cTn id="41" dur="500"/>
                                         <p:tgtEl>
                                           <p:spTgt spid="67"/>
                                         </p:tgtEl>
@@ -4766,21 +4583,112 @@
       </p:grpSp>
       <p:grpSp>
         <p:nvGrpSpPr>
+          <p:cNvPr id="41" name="spin_card_halo_1"/>
+          <p:cNvGrpSpPr/>
+          <p:nvPr/>
+        </p:nvGrpSpPr>
+        <p:grpSpPr>
+          <a:xfrm>
+            <a:off x="13931900" y="2085975"/>
+            <a:ext cx="1447800" cy="1447800"/>
+            <a:chOff x="13931900" y="2085975"/>
+            <a:chExt cx="1447800" cy="1447800"/>
+          </a:xfrm>
+        </p:grpSpPr>
+        <p:sp>
+          <p:nvSpPr>
+            <p:cNvPr id="38" name="Ellipse 38"/>
+            <p:cNvSpPr/>
+            <p:nvPr/>
+          </p:nvSpPr>
+          <p:spPr>
+            <a:xfrm>
+              <a:off x="14027150" y="2181225"/>
+              <a:ext cx="1257300" cy="1257300"/>
+            </a:xfrm>
+            <a:prstGeom prst="ellipse">
+              <a:avLst/>
+            </a:prstGeom>
+            <a:noFill/>
+            <a:ln w="19050">
+              <a:solidFill>
+                <a:srgbClr val="00F0FF">
+                  <a:alpha val="55000"/>
+                </a:srgbClr>
+              </a:solidFill>
+              <a:custDash>
+                <a:ds d="300000" sp="250000"/>
+              </a:custDash>
+            </a:ln>
+          </p:spPr>
+        </p:sp>
+        <p:sp>
+          <p:nvSpPr>
+            <p:cNvPr id="39" name="Ellipse 39"/>
+            <p:cNvSpPr/>
+            <p:nvPr/>
+          </p:nvSpPr>
+          <p:spPr>
+            <a:xfrm>
+              <a:off x="13931900" y="2085975"/>
+              <a:ext cx="1447800" cy="1447800"/>
+            </a:xfrm>
+            <a:prstGeom prst="ellipse">
+              <a:avLst/>
+            </a:prstGeom>
+            <a:noFill/>
+            <a:ln w="9525">
+              <a:solidFill>
+                <a:srgbClr val="A855F7">
+                  <a:alpha val="30000"/>
+                </a:srgbClr>
+              </a:solidFill>
+              <a:custDash>
+                <a:ds d="300000" sp="600000"/>
+              </a:custDash>
+            </a:ln>
+          </p:spPr>
+        </p:sp>
+        <p:sp>
+          <p:nvSpPr>
+            <p:cNvPr id="40" name="Ellipse 40"/>
+            <p:cNvSpPr/>
+            <p:nvPr/>
+          </p:nvSpPr>
+          <p:spPr>
+            <a:xfrm>
+              <a:off x="15246350" y="2771775"/>
+              <a:ext cx="76200" cy="76200"/>
+            </a:xfrm>
+            <a:prstGeom prst="ellipse">
+              <a:avLst/>
+            </a:prstGeom>
+            <a:solidFill>
+              <a:srgbClr val="EC4899"/>
+            </a:solidFill>
+            <a:ln>
+              <a:noFill/>
+            </a:ln>
+          </p:spPr>
+        </p:sp>
+      </p:grpSp>
+      <p:grpSp>
+        <p:nvGrpSpPr>
           <p:cNvPr id="61" name="card_1"/>
           <p:cNvGrpSpPr/>
           <p:nvPr/>
         </p:nvGrpSpPr>
         <p:grpSpPr>
           <a:xfrm>
-            <a:off x="12071350" y="2085975"/>
-            <a:ext cx="5168900" cy="6867525"/>
-            <a:chOff x="12071350" y="2085975"/>
-            <a:chExt cx="5168900" cy="6867525"/>
+            <a:off x="12071350" y="2314575"/>
+            <a:ext cx="5168900" cy="6638925"/>
+            <a:chOff x="12071350" y="2314575"/>
+            <a:chExt cx="5168900" cy="6638925"/>
           </a:xfrm>
         </p:grpSpPr>
         <p:sp>
           <p:nvSpPr>
-            <p:cNvPr id="38" name="Rectangle 38"/>
+            <p:cNvPr id="42" name="Rectangle 42"/>
             <p:cNvSpPr/>
             <p:nvPr/>
           </p:nvSpPr>
@@ -4806,7 +4714,7 @@
         </p:sp>
         <p:sp>
           <p:nvSpPr>
-            <p:cNvPr id="39" name="Rectangle 39"/>
+            <p:cNvPr id="43" name="Rectangle 43"/>
             <p:cNvSpPr/>
             <p:nvPr/>
           </p:nvSpPr>
@@ -4828,97 +4736,6 @@
             </a:ln>
           </p:spPr>
         </p:sp>
-        <p:grpSp>
-          <p:nvGrpSpPr>
-            <p:cNvPr id="43" name="spin_card_halo_1"/>
-            <p:cNvGrpSpPr/>
-            <p:nvPr/>
-          </p:nvGrpSpPr>
-          <p:grpSpPr>
-            <a:xfrm>
-              <a:off x="13931900" y="2085975"/>
-              <a:ext cx="1447800" cy="1447800"/>
-              <a:chOff x="13931900" y="2085975"/>
-              <a:chExt cx="1447800" cy="1447800"/>
-            </a:xfrm>
-          </p:grpSpPr>
-          <p:sp>
-            <p:nvSpPr>
-              <p:cNvPr id="40" name="Ellipse 40"/>
-              <p:cNvSpPr/>
-              <p:nvPr/>
-            </p:nvSpPr>
-            <p:spPr>
-              <a:xfrm>
-                <a:off x="14027150" y="2181225"/>
-                <a:ext cx="1257300" cy="1257300"/>
-              </a:xfrm>
-              <a:prstGeom prst="ellipse">
-                <a:avLst/>
-              </a:prstGeom>
-              <a:noFill/>
-              <a:ln w="19050">
-                <a:solidFill>
-                  <a:srgbClr val="00F0FF">
-                    <a:alpha val="55000"/>
-                  </a:srgbClr>
-                </a:solidFill>
-                <a:custDash>
-                  <a:ds d="300000" sp="250000"/>
-                </a:custDash>
-              </a:ln>
-            </p:spPr>
-          </p:sp>
-          <p:sp>
-            <p:nvSpPr>
-              <p:cNvPr id="41" name="Ellipse 41"/>
-              <p:cNvSpPr/>
-              <p:nvPr/>
-            </p:nvSpPr>
-            <p:spPr>
-              <a:xfrm>
-                <a:off x="13931900" y="2085975"/>
-                <a:ext cx="1447800" cy="1447800"/>
-              </a:xfrm>
-              <a:prstGeom prst="ellipse">
-                <a:avLst/>
-              </a:prstGeom>
-              <a:noFill/>
-              <a:ln w="9525">
-                <a:solidFill>
-                  <a:srgbClr val="A855F7">
-                    <a:alpha val="30000"/>
-                  </a:srgbClr>
-                </a:solidFill>
-                <a:custDash>
-                  <a:ds d="300000" sp="600000"/>
-                </a:custDash>
-              </a:ln>
-            </p:spPr>
-          </p:sp>
-          <p:sp>
-            <p:nvSpPr>
-              <p:cNvPr id="42" name="Ellipse 42"/>
-              <p:cNvSpPr/>
-              <p:nvPr/>
-            </p:nvSpPr>
-            <p:spPr>
-              <a:xfrm>
-                <a:off x="15246350" y="2771775"/>
-                <a:ext cx="76200" cy="76200"/>
-              </a:xfrm>
-              <a:prstGeom prst="ellipse">
-                <a:avLst/>
-              </a:prstGeom>
-              <a:solidFill>
-                <a:srgbClr val="EC4899"/>
-              </a:solidFill>
-              <a:ln>
-                <a:noFill/>
-              </a:ln>
-            </p:spPr>
-          </p:sp>
-        </p:grpSp>
         <p:sp>
           <p:nvSpPr>
             <p:cNvPr id="44" name="Ellipse 44"/>
@@ -5558,21 +5375,112 @@
       </p:grpSp>
       <p:grpSp>
         <p:nvGrpSpPr>
+          <p:cNvPr id="65" name="spin_card_halo_2"/>
+          <p:cNvGrpSpPr/>
+          <p:nvPr/>
+        </p:nvGrpSpPr>
+        <p:grpSpPr>
+          <a:xfrm>
+            <a:off x="8420100" y="2085975"/>
+            <a:ext cx="1447800" cy="1447800"/>
+            <a:chOff x="8420100" y="2085975"/>
+            <a:chExt cx="1447800" cy="1447800"/>
+          </a:xfrm>
+        </p:grpSpPr>
+        <p:sp>
+          <p:nvSpPr>
+            <p:cNvPr id="62" name="Ellipse 62"/>
+            <p:cNvSpPr/>
+            <p:nvPr/>
+          </p:nvSpPr>
+          <p:spPr>
+            <a:xfrm>
+              <a:off x="8515350" y="2181225"/>
+              <a:ext cx="1257300" cy="1257300"/>
+            </a:xfrm>
+            <a:prstGeom prst="ellipse">
+              <a:avLst/>
+            </a:prstGeom>
+            <a:noFill/>
+            <a:ln w="19050">
+              <a:solidFill>
+                <a:srgbClr val="00F0FF">
+                  <a:alpha val="55000"/>
+                </a:srgbClr>
+              </a:solidFill>
+              <a:custDash>
+                <a:ds d="300000" sp="250000"/>
+              </a:custDash>
+            </a:ln>
+          </p:spPr>
+        </p:sp>
+        <p:sp>
+          <p:nvSpPr>
+            <p:cNvPr id="63" name="Ellipse 63"/>
+            <p:cNvSpPr/>
+            <p:nvPr/>
+          </p:nvSpPr>
+          <p:spPr>
+            <a:xfrm>
+              <a:off x="8420100" y="2085975"/>
+              <a:ext cx="1447800" cy="1447800"/>
+            </a:xfrm>
+            <a:prstGeom prst="ellipse">
+              <a:avLst/>
+            </a:prstGeom>
+            <a:noFill/>
+            <a:ln w="9525">
+              <a:solidFill>
+                <a:srgbClr val="A855F7">
+                  <a:alpha val="30000"/>
+                </a:srgbClr>
+              </a:solidFill>
+              <a:custDash>
+                <a:ds d="300000" sp="600000"/>
+              </a:custDash>
+            </a:ln>
+          </p:spPr>
+        </p:sp>
+        <p:sp>
+          <p:nvSpPr>
+            <p:cNvPr id="64" name="Ellipse 64"/>
+            <p:cNvSpPr/>
+            <p:nvPr/>
+          </p:nvSpPr>
+          <p:spPr>
+            <a:xfrm>
+              <a:off x="9734550" y="2771775"/>
+              <a:ext cx="76200" cy="76200"/>
+            </a:xfrm>
+            <a:prstGeom prst="ellipse">
+              <a:avLst/>
+            </a:prstGeom>
+            <a:solidFill>
+              <a:srgbClr val="EC4899"/>
+            </a:solidFill>
+            <a:ln>
+              <a:noFill/>
+            </a:ln>
+          </p:spPr>
+        </p:sp>
+      </p:grpSp>
+      <p:grpSp>
+        <p:nvGrpSpPr>
           <p:cNvPr id="89" name="card_2"/>
           <p:cNvGrpSpPr/>
           <p:nvPr/>
         </p:nvGrpSpPr>
         <p:grpSpPr>
           <a:xfrm>
-            <a:off x="6559550" y="2085975"/>
-            <a:ext cx="5168900" cy="6867525"/>
-            <a:chOff x="6559550" y="2085975"/>
-            <a:chExt cx="5168900" cy="6867525"/>
+            <a:off x="6559550" y="2314575"/>
+            <a:ext cx="5168900" cy="6638925"/>
+            <a:chOff x="6559550" y="2314575"/>
+            <a:chExt cx="5168900" cy="6638925"/>
           </a:xfrm>
         </p:grpSpPr>
         <p:sp>
           <p:nvSpPr>
-            <p:cNvPr id="62" name="Rectangle 62"/>
+            <p:cNvPr id="66" name="Rectangle 66"/>
             <p:cNvSpPr/>
             <p:nvPr/>
           </p:nvSpPr>
@@ -5598,7 +5506,7 @@
         </p:sp>
         <p:sp>
           <p:nvSpPr>
-            <p:cNvPr id="63" name="Rectangle 63"/>
+            <p:cNvPr id="67" name="Rectangle 67"/>
             <p:cNvSpPr/>
             <p:nvPr/>
           </p:nvSpPr>
@@ -5620,97 +5528,6 @@
             </a:ln>
           </p:spPr>
         </p:sp>
-        <p:grpSp>
-          <p:nvGrpSpPr>
-            <p:cNvPr id="67" name="spin_card_halo_2"/>
-            <p:cNvGrpSpPr/>
-            <p:nvPr/>
-          </p:nvGrpSpPr>
-          <p:grpSpPr>
-            <a:xfrm>
-              <a:off x="8420100" y="2085975"/>
-              <a:ext cx="1447800" cy="1447800"/>
-              <a:chOff x="8420100" y="2085975"/>
-              <a:chExt cx="1447800" cy="1447800"/>
-            </a:xfrm>
-          </p:grpSpPr>
-          <p:sp>
-            <p:nvSpPr>
-              <p:cNvPr id="64" name="Ellipse 64"/>
-              <p:cNvSpPr/>
-              <p:nvPr/>
-            </p:nvSpPr>
-            <p:spPr>
-              <a:xfrm>
-                <a:off x="8515350" y="2181225"/>
-                <a:ext cx="1257300" cy="1257300"/>
-              </a:xfrm>
-              <a:prstGeom prst="ellipse">
-                <a:avLst/>
-              </a:prstGeom>
-              <a:noFill/>
-              <a:ln w="19050">
-                <a:solidFill>
-                  <a:srgbClr val="00F0FF">
-                    <a:alpha val="55000"/>
-                  </a:srgbClr>
-                </a:solidFill>
-                <a:custDash>
-                  <a:ds d="300000" sp="250000"/>
-                </a:custDash>
-              </a:ln>
-            </p:spPr>
-          </p:sp>
-          <p:sp>
-            <p:nvSpPr>
-              <p:cNvPr id="65" name="Ellipse 65"/>
-              <p:cNvSpPr/>
-              <p:nvPr/>
-            </p:nvSpPr>
-            <p:spPr>
-              <a:xfrm>
-                <a:off x="8420100" y="2085975"/>
-                <a:ext cx="1447800" cy="1447800"/>
-              </a:xfrm>
-              <a:prstGeom prst="ellipse">
-                <a:avLst/>
-              </a:prstGeom>
-              <a:noFill/>
-              <a:ln w="9525">
-                <a:solidFill>
-                  <a:srgbClr val="A855F7">
-                    <a:alpha val="30000"/>
-                  </a:srgbClr>
-                </a:solidFill>
-                <a:custDash>
-                  <a:ds d="300000" sp="600000"/>
-                </a:custDash>
-              </a:ln>
-            </p:spPr>
-          </p:sp>
-          <p:sp>
-            <p:nvSpPr>
-              <p:cNvPr id="66" name="Ellipse 66"/>
-              <p:cNvSpPr/>
-              <p:nvPr/>
-            </p:nvSpPr>
-            <p:spPr>
-              <a:xfrm>
-                <a:off x="9734550" y="2771775"/>
-                <a:ext cx="76200" cy="76200"/>
-              </a:xfrm>
-              <a:prstGeom prst="ellipse">
-                <a:avLst/>
-              </a:prstGeom>
-              <a:solidFill>
-                <a:srgbClr val="EC4899"/>
-              </a:solidFill>
-              <a:ln>
-                <a:noFill/>
-              </a:ln>
-            </p:spPr>
-          </p:sp>
-        </p:grpSp>
         <p:sp>
           <p:nvSpPr>
             <p:cNvPr id="68" name="Ellipse 68"/>
@@ -6457,21 +6274,112 @@
       </p:grpSp>
       <p:grpSp>
         <p:nvGrpSpPr>
+          <p:cNvPr id="93" name="spin_card_halo_3"/>
+          <p:cNvGrpSpPr/>
+          <p:nvPr/>
+        </p:nvGrpSpPr>
+        <p:grpSpPr>
+          <a:xfrm>
+            <a:off x="2908300" y="2085975"/>
+            <a:ext cx="1447800" cy="1447800"/>
+            <a:chOff x="2908300" y="2085975"/>
+            <a:chExt cx="1447800" cy="1447800"/>
+          </a:xfrm>
+        </p:grpSpPr>
+        <p:sp>
+          <p:nvSpPr>
+            <p:cNvPr id="90" name="Ellipse 90"/>
+            <p:cNvSpPr/>
+            <p:nvPr/>
+          </p:nvSpPr>
+          <p:spPr>
+            <a:xfrm>
+              <a:off x="3003550" y="2181225"/>
+              <a:ext cx="1257300" cy="1257300"/>
+            </a:xfrm>
+            <a:prstGeom prst="ellipse">
+              <a:avLst/>
+            </a:prstGeom>
+            <a:noFill/>
+            <a:ln w="19050">
+              <a:solidFill>
+                <a:srgbClr val="00F0FF">
+                  <a:alpha val="55000"/>
+                </a:srgbClr>
+              </a:solidFill>
+              <a:custDash>
+                <a:ds d="300000" sp="250000"/>
+              </a:custDash>
+            </a:ln>
+          </p:spPr>
+        </p:sp>
+        <p:sp>
+          <p:nvSpPr>
+            <p:cNvPr id="91" name="Ellipse 91"/>
+            <p:cNvSpPr/>
+            <p:nvPr/>
+          </p:nvSpPr>
+          <p:spPr>
+            <a:xfrm>
+              <a:off x="2908300" y="2085975"/>
+              <a:ext cx="1447800" cy="1447800"/>
+            </a:xfrm>
+            <a:prstGeom prst="ellipse">
+              <a:avLst/>
+            </a:prstGeom>
+            <a:noFill/>
+            <a:ln w="9525">
+              <a:solidFill>
+                <a:srgbClr val="A855F7">
+                  <a:alpha val="30000"/>
+                </a:srgbClr>
+              </a:solidFill>
+              <a:custDash>
+                <a:ds d="300000" sp="600000"/>
+              </a:custDash>
+            </a:ln>
+          </p:spPr>
+        </p:sp>
+        <p:sp>
+          <p:nvSpPr>
+            <p:cNvPr id="92" name="Ellipse 92"/>
+            <p:cNvSpPr/>
+            <p:nvPr/>
+          </p:nvSpPr>
+          <p:spPr>
+            <a:xfrm>
+              <a:off x="4222750" y="2771775"/>
+              <a:ext cx="76200" cy="76200"/>
+            </a:xfrm>
+            <a:prstGeom prst="ellipse">
+              <a:avLst/>
+            </a:prstGeom>
+            <a:solidFill>
+              <a:srgbClr val="EC4899"/>
+            </a:solidFill>
+            <a:ln>
+              <a:noFill/>
+            </a:ln>
+          </p:spPr>
+        </p:sp>
+      </p:grpSp>
+      <p:grpSp>
+        <p:nvGrpSpPr>
           <p:cNvPr id="109" name="card_3"/>
           <p:cNvGrpSpPr/>
           <p:nvPr/>
         </p:nvGrpSpPr>
         <p:grpSpPr>
           <a:xfrm>
-            <a:off x="1047750" y="2085975"/>
-            <a:ext cx="5168900" cy="6867525"/>
-            <a:chOff x="1047750" y="2085975"/>
-            <a:chExt cx="5168900" cy="6867525"/>
+            <a:off x="1047750" y="2314575"/>
+            <a:ext cx="5168900" cy="6638925"/>
+            <a:chOff x="1047750" y="2314575"/>
+            <a:chExt cx="5168900" cy="6638925"/>
           </a:xfrm>
         </p:grpSpPr>
         <p:sp>
           <p:nvSpPr>
-            <p:cNvPr id="90" name="Rectangle 90"/>
+            <p:cNvPr id="94" name="Rectangle 94"/>
             <p:cNvSpPr/>
             <p:nvPr/>
           </p:nvSpPr>
@@ -6497,7 +6405,7 @@
         </p:sp>
         <p:sp>
           <p:nvSpPr>
-            <p:cNvPr id="91" name="Rectangle 91"/>
+            <p:cNvPr id="95" name="Rectangle 95"/>
             <p:cNvSpPr/>
             <p:nvPr/>
           </p:nvSpPr>
@@ -6519,97 +6427,6 @@
             </a:ln>
           </p:spPr>
         </p:sp>
-        <p:grpSp>
-          <p:nvGrpSpPr>
-            <p:cNvPr id="95" name="spin_card_halo_3"/>
-            <p:cNvGrpSpPr/>
-            <p:nvPr/>
-          </p:nvGrpSpPr>
-          <p:grpSpPr>
-            <a:xfrm>
-              <a:off x="2908300" y="2085975"/>
-              <a:ext cx="1447800" cy="1447800"/>
-              <a:chOff x="2908300" y="2085975"/>
-              <a:chExt cx="1447800" cy="1447800"/>
-            </a:xfrm>
-          </p:grpSpPr>
-          <p:sp>
-            <p:nvSpPr>
-              <p:cNvPr id="92" name="Ellipse 92"/>
-              <p:cNvSpPr/>
-              <p:nvPr/>
-            </p:nvSpPr>
-            <p:spPr>
-              <a:xfrm>
-                <a:off x="3003550" y="2181225"/>
-                <a:ext cx="1257300" cy="1257300"/>
-              </a:xfrm>
-              <a:prstGeom prst="ellipse">
-                <a:avLst/>
-              </a:prstGeom>
-              <a:noFill/>
-              <a:ln w="19050">
-                <a:solidFill>
-                  <a:srgbClr val="00F0FF">
-                    <a:alpha val="55000"/>
-                  </a:srgbClr>
-                </a:solidFill>
-                <a:custDash>
-                  <a:ds d="300000" sp="250000"/>
-                </a:custDash>
-              </a:ln>
-            </p:spPr>
-          </p:sp>
-          <p:sp>
-            <p:nvSpPr>
-              <p:cNvPr id="93" name="Ellipse 93"/>
-              <p:cNvSpPr/>
-              <p:nvPr/>
-            </p:nvSpPr>
-            <p:spPr>
-              <a:xfrm>
-                <a:off x="2908300" y="2085975"/>
-                <a:ext cx="1447800" cy="1447800"/>
-              </a:xfrm>
-              <a:prstGeom prst="ellipse">
-                <a:avLst/>
-              </a:prstGeom>
-              <a:noFill/>
-              <a:ln w="9525">
-                <a:solidFill>
-                  <a:srgbClr val="A855F7">
-                    <a:alpha val="30000"/>
-                  </a:srgbClr>
-                </a:solidFill>
-                <a:custDash>
-                  <a:ds d="300000" sp="600000"/>
-                </a:custDash>
-              </a:ln>
-            </p:spPr>
-          </p:sp>
-          <p:sp>
-            <p:nvSpPr>
-              <p:cNvPr id="94" name="Ellipse 94"/>
-              <p:cNvSpPr/>
-              <p:nvPr/>
-            </p:nvSpPr>
-            <p:spPr>
-              <a:xfrm>
-                <a:off x="4222750" y="2771775"/>
-                <a:ext cx="76200" cy="76200"/>
-              </a:xfrm>
-              <a:prstGeom prst="ellipse">
-                <a:avLst/>
-              </a:prstGeom>
-              <a:solidFill>
-                <a:srgbClr val="EC4899"/>
-              </a:solidFill>
-              <a:ln>
-                <a:noFill/>
-              </a:ln>
-            </p:spPr>
-          </p:sp>
-        </p:grpSp>
         <p:sp>
           <p:nvSpPr>
             <p:cNvPr id="96" name="Ellipse 96"/>
@@ -7047,7 +6864,7 @@
   </p:clrMapOvr>
   <mc:AlternateContent xmlns:mc="http://schemas.openxmlformats.org/markup-compatibility/2006">
     <mc:Choice xmlns:p159="http://schemas.microsoft.com/office/powerpoint/2015/09/main" Requires="p159">
-      <p:transition xmlns:p14="http://schemas.microsoft.com/office/powerpoint/2010/main" p14:dur="400">
+      <p:transition xmlns:p14="http://schemas.microsoft.com/office/powerpoint/2010/main" p14:dur="500">
         <p159:morph option="byObject"/>
       </p:transition>
     </mc:Choice>
@@ -7106,7 +6923,7 @@
                                     </p:set>
                                     <p:animEffect transition="in" filter="wipe(down)">
                                       <p:cBhvr>
-                                        <p:cTn id="7" dur="400"/>
+                                        <p:cTn id="7" dur="500"/>
                                         <p:tgtEl>
                                           <p:spTgt spid="5"/>
                                         </p:tgtEl>
@@ -7121,24 +6938,184 @@
                         <p:par>
                           <p:cTn id="8" fill="hold">
                             <p:stCondLst>
-                              <p:cond delay="400"/>
+                              <p:cond delay="0"/>
                             </p:stCondLst>
                             <p:childTnLst>
                               <p:par>
-                                <p:cTn xmlns:p="http://schemas.openxmlformats.org/presentationml/2006/main" id="9" presetID="49" presetClass="entr" presetSubtype="0" decel="100000" fill="hold" grpId="0" nodeType="afterEffect">
+                                <p:cTn xmlns:p="http://schemas.openxmlformats.org/presentationml/2006/main" id="9" presetID="8" presetClass="emph" presetSubtype="0" fill="hold" grpId="0" nodeType="withEffect" repeatCount="999000">
+                                  <p:stCondLst>
+                                    <p:cond delay="0"/>
+                                  </p:stCondLst>
+                                  <p:childTnLst>
+                                    <p:animRot by="21600000">
+                                      <p:cBhvr>
+                                        <p:cTn id="10" dur="8000" fill="hold"/>
+                                        <p:tgtEl>
+                                          <p:spTgt spid="17"/>
+                                        </p:tgtEl>
+                                        <p:attrNameLst>
+                                          <p:attrName>r</p:attrName>
+                                        </p:attrNameLst>
+                                      </p:cBhvr>
+                                    </p:animRot>
+                                  </p:childTnLst>
+                                </p:cTn>
+                              </p:par>
+                            </p:childTnLst>
+                          </p:cTn>
+                        </p:par>
+                        <p:par>
+                          <p:cTn id="11" fill="hold">
+                            <p:stCondLst>
+                              <p:cond delay="0"/>
+                            </p:stCondLst>
+                            <p:childTnLst>
+                              <p:par>
+                                <p:cTn xmlns:p="http://schemas.openxmlformats.org/presentationml/2006/main" id="12" presetID="8" presetClass="emph" presetSubtype="0" fill="hold" grpId="0" nodeType="withEffect" repeatCount="999000">
+                                  <p:stCondLst>
+                                    <p:cond delay="0"/>
+                                  </p:stCondLst>
+                                  <p:childTnLst>
+                                    <p:animRot by="21600000">
+                                      <p:cBhvr>
+                                        <p:cTn id="13" dur="12000" fill="hold"/>
+                                        <p:tgtEl>
+                                          <p:spTgt spid="34"/>
+                                        </p:tgtEl>
+                                        <p:attrNameLst>
+                                          <p:attrName>r</p:attrName>
+                                        </p:attrNameLst>
+                                      </p:cBhvr>
+                                    </p:animRot>
+                                  </p:childTnLst>
+                                </p:cTn>
+                              </p:par>
+                            </p:childTnLst>
+                          </p:cTn>
+                        </p:par>
+                        <p:par>
+                          <p:cTn id="14" fill="hold">
+                            <p:stCondLst>
+                              <p:cond delay="0"/>
+                            </p:stCondLst>
+                            <p:childTnLst>
+                              <p:par>
+                                <p:cTn xmlns:p="http://schemas.openxmlformats.org/presentationml/2006/main" id="15" presetID="8" presetClass="emph" presetSubtype="0" fill="hold" grpId="0" nodeType="withEffect" repeatCount="999000">
+                                  <p:stCondLst>
+                                    <p:cond delay="0"/>
+                                  </p:stCondLst>
+                                  <p:childTnLst>
+                                    <p:animRot by="21600000">
+                                      <p:cBhvr>
+                                        <p:cTn id="16" dur="6000" fill="hold"/>
+                                        <p:tgtEl>
+                                          <p:spTgt spid="41"/>
+                                        </p:tgtEl>
+                                        <p:attrNameLst>
+                                          <p:attrName>r</p:attrName>
+                                        </p:attrNameLst>
+                                      </p:cBhvr>
+                                    </p:animRot>
+                                  </p:childTnLst>
+                                </p:cTn>
+                              </p:par>
+                            </p:childTnLst>
+                          </p:cTn>
+                        </p:par>
+                        <p:par>
+                          <p:cTn id="17" fill="hold">
+                            <p:stCondLst>
+                              <p:cond delay="0"/>
+                            </p:stCondLst>
+                            <p:childTnLst>
+                              <p:par>
+                                <p:cTn xmlns:p="http://schemas.openxmlformats.org/presentationml/2006/main" id="18" presetID="22" presetClass="entr" presetSubtype="4" fill="hold" grpId="0" nodeType="afterEffect">
                                   <p:stCondLst>
                                     <p:cond delay="350"/>
                                   </p:stCondLst>
                                   <p:childTnLst>
                                     <p:set>
                                       <p:cBhvr>
-                                        <p:cTn id="10" dur="1" fill="hold">
+                                        <p:cTn id="19" dur="1" fill="hold">
                                           <p:stCondLst>
                                             <p:cond delay="0"/>
                                           </p:stCondLst>
                                         </p:cTn>
                                         <p:tgtEl>
-                                          <p:spTgt spid="17"/>
+                                          <p:spTgt spid="61"/>
+                                        </p:tgtEl>
+                                        <p:attrNameLst>
+                                          <p:attrName>style.visibility</p:attrName>
+                                        </p:attrNameLst>
+                                      </p:cBhvr>
+                                      <p:to>
+                                        <p:strVal val="visible"/>
+                                      </p:to>
+                                    </p:set>
+                                    <p:animEffect transition="in" filter="wipe(down)">
+                                      <p:cBhvr>
+                                        <p:cTn id="20" dur="500"/>
+                                        <p:tgtEl>
+                                          <p:spTgt spid="61"/>
+                                        </p:tgtEl>
+                                      </p:cBhvr>
+                                    </p:animEffect>
+                                  </p:childTnLst>
+                                </p:cTn>
+                              </p:par>
+                            </p:childTnLst>
+                          </p:cTn>
+                        </p:par>
+                        <p:par>
+                          <p:cTn id="21" fill="hold">
+                            <p:stCondLst>
+                              <p:cond delay="350"/>
+                            </p:stCondLst>
+                            <p:childTnLst>
+                              <p:par>
+                                <p:cTn xmlns:p="http://schemas.openxmlformats.org/presentationml/2006/main" id="22" presetID="8" presetClass="emph" presetSubtype="0" fill="hold" grpId="0" nodeType="withEffect" repeatCount="999000">
+                                  <p:stCondLst>
+                                    <p:cond delay="0"/>
+                                  </p:stCondLst>
+                                  <p:childTnLst>
+                                    <p:animRot by="21600000">
+                                      <p:cBhvr>
+                                        <p:cTn id="23" dur="6000" fill="hold"/>
+                                        <p:tgtEl>
+                                          <p:spTgt spid="65"/>
+                                        </p:tgtEl>
+                                        <p:attrNameLst>
+                                          <p:attrName>r</p:attrName>
+                                        </p:attrNameLst>
+                                      </p:cBhvr>
+                                    </p:animRot>
+                                  </p:childTnLst>
+                                </p:cTn>
+                              </p:par>
+                            </p:childTnLst>
+                          </p:cTn>
+                        </p:par>
+                        <p:par>
+                          <p:cTn id="24" fill="hold">
+                            <p:stCondLst>
+                              <p:cond delay="350"/>
+                            </p:stCondLst>
+                            <p:childTnLst>
+                              <p:par>
+                                <p:cTn xmlns:p="http://schemas.openxmlformats.org/presentationml/2006/main" id="25" presetID="23" presetClass="entr" presetSubtype="16" fill="hold" grpId="0" nodeType="afterEffect">
+                                  <p:stCondLst>
+                                    <p:cond delay="350"/>
+                                  </p:stCondLst>
+                                  <p:childTnLst>
+                                    <p:set>
+                                      <p:cBhvr>
+                                        <p:cTn id="26" dur="1" fill="hold">
+                                          <p:stCondLst>
+                                            <p:cond delay="0"/>
+                                          </p:stCondLst>
+                                        </p:cTn>
+                                        <p:tgtEl>
+                                          <p:spTgt spid="89"/>
                                         </p:tgtEl>
                                         <p:attrNameLst>
                                           <p:attrName>style.visibility</p:attrName>
@@ -7150,9 +7127,9 @@
                                     </p:set>
                                     <p:anim calcmode="lin" valueType="num">
                                       <p:cBhvr>
-                                        <p:cTn id="11" dur="400" fill="hold"/>
+                                        <p:cTn id="27" dur="500" fill="hold"/>
                                         <p:tgtEl>
-                                          <p:spTgt spid="17"/>
+                                          <p:spTgt spid="89"/>
                                         </p:tgtEl>
                                         <p:attrNameLst>
                                           <p:attrName>ppt_w</p:attrName>
@@ -7173,9 +7150,9 @@
                                     </p:anim>
                                     <p:anim calcmode="lin" valueType="num">
                                       <p:cBhvr>
-                                        <p:cTn id="12" dur="400" fill="hold"/>
+                                        <p:cTn id="28" dur="500" fill="hold"/>
                                         <p:tgtEl>
-                                          <p:spTgt spid="17"/>
+                                          <p:spTgt spid="89"/>
                                         </p:tgtEl>
                                         <p:attrNameLst>
                                           <p:attrName>ppt_h</p:attrName>
@@ -7194,37 +7171,6 @@
                                         </p:tav>
                                       </p:tavLst>
                                     </p:anim>
-                                    <p:anim calcmode="lin" valueType="num">
-                                      <p:cBhvr>
-                                        <p:cTn id="13" dur="400" fill="hold"/>
-                                        <p:tgtEl>
-                                          <p:spTgt spid="17"/>
-                                        </p:tgtEl>
-                                        <p:attrNameLst>
-                                          <p:attrName>style.rotation</p:attrName>
-                                        </p:attrNameLst>
-                                      </p:cBhvr>
-                                      <p:tavLst>
-                                        <p:tav tm="0">
-                                          <p:val>
-                                            <p:fltVal val="360"/>
-                                          </p:val>
-                                        </p:tav>
-                                        <p:tav tm="100000">
-                                          <p:val>
-                                            <p:fltVal val="0"/>
-                                          </p:val>
-                                        </p:tav>
-                                      </p:tavLst>
-                                    </p:anim>
-                                    <p:animEffect transition="in" filter="fade">
-                                      <p:cBhvr>
-                                        <p:cTn id="14" dur="400"/>
-                                        <p:tgtEl>
-                                          <p:spTgt spid="17"/>
-                                        </p:tgtEl>
-                                      </p:cBhvr>
-                                    </p:animEffect>
                                   </p:childTnLst>
                                 </p:cTn>
                               </p:par>
@@ -7232,112 +7178,28 @@
                           </p:cTn>
                         </p:par>
                         <p:par>
-                          <p:cTn id="15" fill="hold">
+                          <p:cTn id="29" fill="hold">
                             <p:stCondLst>
-                              <p:cond delay="1150"/>
+                              <p:cond delay="700"/>
                             </p:stCondLst>
                             <p:childTnLst>
                               <p:par>
-                                <p:cTn xmlns:p="http://schemas.openxmlformats.org/presentationml/2006/main" id="16" presetID="49" presetClass="entr" presetSubtype="0" decel="100000" fill="hold" grpId="0" nodeType="afterEffect">
+                                <p:cTn xmlns:p="http://schemas.openxmlformats.org/presentationml/2006/main" id="30" presetID="8" presetClass="emph" presetSubtype="0" fill="hold" grpId="0" nodeType="withEffect" repeatCount="999000">
                                   <p:stCondLst>
-                                    <p:cond delay="350"/>
+                                    <p:cond delay="0"/>
                                   </p:stCondLst>
                                   <p:childTnLst>
-                                    <p:set>
+                                    <p:animRot by="21600000">
                                       <p:cBhvr>
-                                        <p:cTn id="17" dur="1" fill="hold">
-                                          <p:stCondLst>
-                                            <p:cond delay="0"/>
-                                          </p:stCondLst>
-                                        </p:cTn>
+                                        <p:cTn id="31" dur="6000" fill="hold"/>
                                         <p:tgtEl>
-                                          <p:spTgt spid="34"/>
+                                          <p:spTgt spid="93"/>
                                         </p:tgtEl>
                                         <p:attrNameLst>
-                                          <p:attrName>style.visibility</p:attrName>
+                                          <p:attrName>r</p:attrName>
                                         </p:attrNameLst>
                                       </p:cBhvr>
-                                      <p:to>
-                                        <p:strVal val="visible"/>
-                                      </p:to>
-                                    </p:set>
-                                    <p:anim calcmode="lin" valueType="num">
-                                      <p:cBhvr>
-                                        <p:cTn id="18" dur="400" fill="hold"/>
-                                        <p:tgtEl>
-                                          <p:spTgt spid="34"/>
-                                        </p:tgtEl>
-                                        <p:attrNameLst>
-                                          <p:attrName>ppt_w</p:attrName>
-                                        </p:attrNameLst>
-                                      </p:cBhvr>
-                                      <p:tavLst>
-                                        <p:tav tm="0">
-                                          <p:val>
-                                            <p:fltVal val="0"/>
-                                          </p:val>
-                                        </p:tav>
-                                        <p:tav tm="100000">
-                                          <p:val>
-                                            <p:strVal val="#ppt_w"/>
-                                          </p:val>
-                                        </p:tav>
-                                      </p:tavLst>
-                                    </p:anim>
-                                    <p:anim calcmode="lin" valueType="num">
-                                      <p:cBhvr>
-                                        <p:cTn id="19" dur="400" fill="hold"/>
-                                        <p:tgtEl>
-                                          <p:spTgt spid="34"/>
-                                        </p:tgtEl>
-                                        <p:attrNameLst>
-                                          <p:attrName>ppt_h</p:attrName>
-                                        </p:attrNameLst>
-                                      </p:cBhvr>
-                                      <p:tavLst>
-                                        <p:tav tm="0">
-                                          <p:val>
-                                            <p:fltVal val="0"/>
-                                          </p:val>
-                                        </p:tav>
-                                        <p:tav tm="100000">
-                                          <p:val>
-                                            <p:strVal val="#ppt_h"/>
-                                          </p:val>
-                                        </p:tav>
-                                      </p:tavLst>
-                                    </p:anim>
-                                    <p:anim calcmode="lin" valueType="num">
-                                      <p:cBhvr>
-                                        <p:cTn id="20" dur="400" fill="hold"/>
-                                        <p:tgtEl>
-                                          <p:spTgt spid="34"/>
-                                        </p:tgtEl>
-                                        <p:attrNameLst>
-                                          <p:attrName>style.rotation</p:attrName>
-                                        </p:attrNameLst>
-                                      </p:cBhvr>
-                                      <p:tavLst>
-                                        <p:tav tm="0">
-                                          <p:val>
-                                            <p:fltVal val="360"/>
-                                          </p:val>
-                                        </p:tav>
-                                        <p:tav tm="100000">
-                                          <p:val>
-                                            <p:fltVal val="0"/>
-                                          </p:val>
-                                        </p:tav>
-                                      </p:tavLst>
-                                    </p:anim>
-                                    <p:animEffect transition="in" filter="fade">
-                                      <p:cBhvr>
-                                        <p:cTn id="21" dur="400"/>
-                                        <p:tgtEl>
-                                          <p:spTgt spid="34"/>
-                                        </p:tgtEl>
-                                      </p:cBhvr>
-                                    </p:animEffect>
+                                    </p:animRot>
                                   </p:childTnLst>
                                 </p:cTn>
                               </p:par>
@@ -7345,108 +7207,20 @@
                           </p:cTn>
                         </p:par>
                         <p:par>
-                          <p:cTn id="22" fill="hold">
+                          <p:cTn id="32" fill="hold">
                             <p:stCondLst>
-                              <p:cond delay="1900"/>
+                              <p:cond delay="700"/>
                             </p:stCondLst>
                             <p:childTnLst>
                               <p:par>
-                                <p:cTn xmlns:p="http://schemas.openxmlformats.org/presentationml/2006/main" id="23" presetID="10" presetClass="entr" presetSubtype="0" fill="hold" grpId="0" nodeType="afterEffect">
+                                <p:cTn xmlns:p="http://schemas.openxmlformats.org/presentationml/2006/main" id="33" presetID="22" presetClass="entr" presetSubtype="4" fill="hold" grpId="0" nodeType="afterEffect">
                                   <p:stCondLst>
                                     <p:cond delay="350"/>
                                   </p:stCondLst>
                                   <p:childTnLst>
                                     <p:set>
                                       <p:cBhvr>
-                                        <p:cTn id="24" dur="1" fill="hold">
-                                          <p:stCondLst>
-                                            <p:cond delay="0"/>
-                                          </p:stCondLst>
-                                        </p:cTn>
-                                        <p:tgtEl>
-                                          <p:spTgt spid="61"/>
-                                        </p:tgtEl>
-                                        <p:attrNameLst>
-                                          <p:attrName>style.visibility</p:attrName>
-                                        </p:attrNameLst>
-                                      </p:cBhvr>
-                                      <p:to>
-                                        <p:strVal val="visible"/>
-                                      </p:to>
-                                    </p:set>
-                                    <p:animEffect transition="in" filter="fade">
-                                      <p:cBhvr>
-                                        <p:cTn id="25" dur="400"/>
-                                        <p:tgtEl>
-                                          <p:spTgt spid="61"/>
-                                        </p:tgtEl>
-                                      </p:cBhvr>
-                                    </p:animEffect>
-                                  </p:childTnLst>
-                                </p:cTn>
-                              </p:par>
-                            </p:childTnLst>
-                          </p:cTn>
-                        </p:par>
-                        <p:par>
-                          <p:cTn id="26" fill="hold">
-                            <p:stCondLst>
-                              <p:cond delay="2650"/>
-                            </p:stCondLst>
-                            <p:childTnLst>
-                              <p:par>
-                                <p:cTn xmlns:p="http://schemas.openxmlformats.org/presentationml/2006/main" id="27" presetID="22" presetClass="entr" presetSubtype="4" fill="hold" grpId="0" nodeType="afterEffect">
-                                  <p:stCondLst>
-                                    <p:cond delay="350"/>
-                                  </p:stCondLst>
-                                  <p:childTnLst>
-                                    <p:set>
-                                      <p:cBhvr>
-                                        <p:cTn id="28" dur="1" fill="hold">
-                                          <p:stCondLst>
-                                            <p:cond delay="0"/>
-                                          </p:stCondLst>
-                                        </p:cTn>
-                                        <p:tgtEl>
-                                          <p:spTgt spid="89"/>
-                                        </p:tgtEl>
-                                        <p:attrNameLst>
-                                          <p:attrName>style.visibility</p:attrName>
-                                        </p:attrNameLst>
-                                      </p:cBhvr>
-                                      <p:to>
-                                        <p:strVal val="visible"/>
-                                      </p:to>
-                                    </p:set>
-                                    <p:animEffect transition="in" filter="wipe(down)">
-                                      <p:cBhvr>
-                                        <p:cTn id="29" dur="400"/>
-                                        <p:tgtEl>
-                                          <p:spTgt spid="89"/>
-                                        </p:tgtEl>
-                                      </p:cBhvr>
-                                    </p:animEffect>
-                                  </p:childTnLst>
-                                </p:cTn>
-                              </p:par>
-                            </p:childTnLst>
-                          </p:cTn>
-                        </p:par>
-                        <p:par>
-                          <p:cTn id="30" fill="hold">
-                            <p:stCondLst>
-                              <p:cond delay="3400"/>
-                            </p:stCondLst>
-                            <p:childTnLst>
-                              <p:par>
-                                <p:cTn xmlns:p="http://schemas.openxmlformats.org/presentationml/2006/main" id="31" presetID="2" presetClass="entr" presetSubtype="4" fill="hold" grpId="0" nodeType="afterEffect">
-                                  <p:stCondLst>
-                                    <p:cond delay="350"/>
-                                  </p:stCondLst>
-                                  <p:childTnLst>
-                                    <p:set>
-                                      <p:cBhvr>
-                                        <p:cTn id="32" dur="1" fill="hold">
+                                        <p:cTn id="34" dur="1" fill="hold">
                                           <p:stCondLst>
                                             <p:cond delay="0"/>
                                           </p:stCondLst>
@@ -7462,52 +7236,14 @@
                                         <p:strVal val="visible"/>
                                       </p:to>
                                     </p:set>
-                                    <p:anim calcmode="lin" valueType="num">
-                                      <p:cBhvr additive="base">
-                                        <p:cTn id="33" dur="400" fill="hold"/>
+                                    <p:animEffect transition="in" filter="wipe(down)">
+                                      <p:cBhvr>
+                                        <p:cTn id="35" dur="500"/>
                                         <p:tgtEl>
                                           <p:spTgt spid="109"/>
                                         </p:tgtEl>
-                                        <p:attrNameLst>
-                                          <p:attrName>ppt_x</p:attrName>
-                                        </p:attrNameLst>
                                       </p:cBhvr>
-                                      <p:tavLst>
-                                        <p:tav tm="0">
-                                          <p:val>
-                                            <p:strVal val="#ppt_x"/>
-                                          </p:val>
-                                        </p:tav>
-                                        <p:tav tm="100000">
-                                          <p:val>
-                                            <p:strVal val="#ppt_x"/>
-                                          </p:val>
-                                        </p:tav>
-                                      </p:tavLst>
-                                    </p:anim>
-                                    <p:anim calcmode="lin" valueType="num">
-                                      <p:cBhvr additive="base">
-                                        <p:cTn id="34" dur="400" fill="hold"/>
-                                        <p:tgtEl>
-                                          <p:spTgt spid="109"/>
-                                        </p:tgtEl>
-                                        <p:attrNameLst>
-                                          <p:attrName>ppt_y</p:attrName>
-                                        </p:attrNameLst>
-                                      </p:cBhvr>
-                                      <p:tavLst>
-                                        <p:tav tm="0">
-                                          <p:val>
-                                            <p:strVal val="1+#ppt_h/2"/>
-                                          </p:val>
-                                        </p:tav>
-                                        <p:tav tm="100000">
-                                          <p:val>
-                                            <p:strVal val="#ppt_y"/>
-                                          </p:val>
-                                        </p:tav>
-                                      </p:tavLst>
-                                    </p:anim>
+                                    </p:animEffect>
                                   </p:childTnLst>
                                 </p:cTn>
                               </p:par>
@@ -8622,131 +8358,131 @@
       </p:sp>
       <p:grpSp>
         <p:nvGrpSpPr>
+          <p:cNvPr id="44" name="spin_step_orbit_1"/>
+          <p:cNvGrpSpPr/>
+          <p:nvPr/>
+        </p:nvGrpSpPr>
+        <p:grpSpPr>
+          <a:xfrm>
+            <a:off x="13246100" y="2095500"/>
+            <a:ext cx="2476500" cy="2476500"/>
+            <a:chOff x="13246100" y="2095500"/>
+            <a:chExt cx="2476500" cy="2476500"/>
+          </a:xfrm>
+        </p:grpSpPr>
+        <p:sp>
+          <p:nvSpPr>
+            <p:cNvPr id="40" name="Ellipse 40"/>
+            <p:cNvSpPr/>
+            <p:nvPr/>
+          </p:nvSpPr>
+          <p:spPr>
+            <a:xfrm>
+              <a:off x="13388975" y="2238375"/>
+              <a:ext cx="2190750" cy="2190750"/>
+            </a:xfrm>
+            <a:prstGeom prst="ellipse">
+              <a:avLst/>
+            </a:prstGeom>
+            <a:noFill/>
+            <a:ln w="23812">
+              <a:solidFill>
+                <a:srgbClr val="00F0FF">
+                  <a:alpha val="60000"/>
+                </a:srgbClr>
+              </a:solidFill>
+              <a:custDash>
+                <a:ds d="320000" sp="240000"/>
+              </a:custDash>
+            </a:ln>
+          </p:spPr>
+        </p:sp>
+        <p:sp>
+          <p:nvSpPr>
+            <p:cNvPr id="41" name="Ellipse 41"/>
+            <p:cNvSpPr/>
+            <p:nvPr/>
+          </p:nvSpPr>
+          <p:spPr>
+            <a:xfrm>
+              <a:off x="13246100" y="2095500"/>
+              <a:ext cx="2476500" cy="2476500"/>
+            </a:xfrm>
+            <a:prstGeom prst="ellipse">
+              <a:avLst/>
+            </a:prstGeom>
+            <a:noFill/>
+            <a:ln w="11430">
+              <a:solidFill>
+                <a:srgbClr val="A855F7">
+                  <a:alpha val="40000"/>
+                </a:srgbClr>
+              </a:solidFill>
+              <a:custDash>
+                <a:ds d="333333" sp="666667"/>
+              </a:custDash>
+            </a:ln>
+          </p:spPr>
+        </p:sp>
+        <p:sp>
+          <p:nvSpPr>
+            <p:cNvPr id="42" name="Ellipse 42"/>
+            <p:cNvSpPr/>
+            <p:nvPr/>
+          </p:nvSpPr>
+          <p:spPr>
+            <a:xfrm>
+              <a:off x="15527338" y="3281362"/>
+              <a:ext cx="104775" cy="104775"/>
+            </a:xfrm>
+            <a:prstGeom prst="ellipse">
+              <a:avLst/>
+            </a:prstGeom>
+            <a:solidFill>
+              <a:srgbClr val="EC4899"/>
+            </a:solidFill>
+            <a:ln>
+              <a:noFill/>
+            </a:ln>
+          </p:spPr>
+        </p:sp>
+        <p:sp>
+          <p:nvSpPr>
+            <p:cNvPr id="43" name="Ellipse 43"/>
+            <p:cNvSpPr/>
+            <p:nvPr/>
+          </p:nvSpPr>
+          <p:spPr>
+            <a:xfrm>
+              <a:off x="13346112" y="3290888"/>
+              <a:ext cx="85725" cy="85725"/>
+            </a:xfrm>
+            <a:prstGeom prst="ellipse">
+              <a:avLst/>
+            </a:prstGeom>
+            <a:solidFill>
+              <a:srgbClr val="00F0FF"/>
+            </a:solidFill>
+            <a:ln>
+              <a:noFill/>
+            </a:ln>
+          </p:spPr>
+        </p:sp>
+      </p:grpSp>
+      <p:grpSp>
+        <p:nvGrpSpPr>
           <p:cNvPr id="61" name="step_node_1"/>
           <p:cNvGrpSpPr/>
           <p:nvPr/>
         </p:nvGrpSpPr>
         <p:grpSpPr>
           <a:xfrm>
-            <a:off x="11899900" y="2095500"/>
-            <a:ext cx="5168900" cy="6858000"/>
-            <a:chOff x="11899900" y="2095500"/>
-            <a:chExt cx="5168900" cy="6858000"/>
+            <a:off x="11899900" y="2381250"/>
+            <a:ext cx="5168900" cy="6572250"/>
+            <a:chOff x="11899900" y="2381250"/>
+            <a:chExt cx="5168900" cy="6572250"/>
           </a:xfrm>
         </p:grpSpPr>
-        <p:grpSp>
-          <p:nvGrpSpPr>
-            <p:cNvPr id="44" name="spin_step_orbit_1"/>
-            <p:cNvGrpSpPr/>
-            <p:nvPr/>
-          </p:nvGrpSpPr>
-          <p:grpSpPr>
-            <a:xfrm>
-              <a:off x="13246100" y="2095500"/>
-              <a:ext cx="2476500" cy="2476500"/>
-              <a:chOff x="13246100" y="2095500"/>
-              <a:chExt cx="2476500" cy="2476500"/>
-            </a:xfrm>
-          </p:grpSpPr>
-          <p:sp>
-            <p:nvSpPr>
-              <p:cNvPr id="40" name="Ellipse 40"/>
-              <p:cNvSpPr/>
-              <p:nvPr/>
-            </p:nvSpPr>
-            <p:spPr>
-              <a:xfrm>
-                <a:off x="13388975" y="2238375"/>
-                <a:ext cx="2190750" cy="2190750"/>
-              </a:xfrm>
-              <a:prstGeom prst="ellipse">
-                <a:avLst/>
-              </a:prstGeom>
-              <a:noFill/>
-              <a:ln w="23812">
-                <a:solidFill>
-                  <a:srgbClr val="00F0FF">
-                    <a:alpha val="60000"/>
-                  </a:srgbClr>
-                </a:solidFill>
-                <a:custDash>
-                  <a:ds d="320000" sp="240000"/>
-                </a:custDash>
-              </a:ln>
-            </p:spPr>
-          </p:sp>
-          <p:sp>
-            <p:nvSpPr>
-              <p:cNvPr id="41" name="Ellipse 41"/>
-              <p:cNvSpPr/>
-              <p:nvPr/>
-            </p:nvSpPr>
-            <p:spPr>
-              <a:xfrm>
-                <a:off x="13246100" y="2095500"/>
-                <a:ext cx="2476500" cy="2476500"/>
-              </a:xfrm>
-              <a:prstGeom prst="ellipse">
-                <a:avLst/>
-              </a:prstGeom>
-              <a:noFill/>
-              <a:ln w="11430">
-                <a:solidFill>
-                  <a:srgbClr val="A855F7">
-                    <a:alpha val="40000"/>
-                  </a:srgbClr>
-                </a:solidFill>
-                <a:custDash>
-                  <a:ds d="333333" sp="666667"/>
-                </a:custDash>
-              </a:ln>
-            </p:spPr>
-          </p:sp>
-          <p:sp>
-            <p:nvSpPr>
-              <p:cNvPr id="42" name="Ellipse 42"/>
-              <p:cNvSpPr/>
-              <p:nvPr/>
-            </p:nvSpPr>
-            <p:spPr>
-              <a:xfrm>
-                <a:off x="15527338" y="3281362"/>
-                <a:ext cx="104775" cy="104775"/>
-              </a:xfrm>
-              <a:prstGeom prst="ellipse">
-                <a:avLst/>
-              </a:prstGeom>
-              <a:solidFill>
-                <a:srgbClr val="EC4899"/>
-              </a:solidFill>
-              <a:ln>
-                <a:noFill/>
-              </a:ln>
-            </p:spPr>
-          </p:sp>
-          <p:sp>
-            <p:nvSpPr>
-              <p:cNvPr id="43" name="Ellipse 43"/>
-              <p:cNvSpPr/>
-              <p:nvPr/>
-            </p:nvSpPr>
-            <p:spPr>
-              <a:xfrm>
-                <a:off x="13346112" y="3290888"/>
-                <a:ext cx="85725" cy="85725"/>
-              </a:xfrm>
-              <a:prstGeom prst="ellipse">
-                <a:avLst/>
-              </a:prstGeom>
-              <a:solidFill>
-                <a:srgbClr val="00F0FF"/>
-              </a:solidFill>
-              <a:ln>
-                <a:noFill/>
-              </a:ln>
-            </p:spPr>
-          </p:sp>
-        </p:grpSp>
         <p:sp>
           <p:nvSpPr>
             <p:cNvPr id="45" name="Ellipse 45"/>
@@ -9287,131 +9023,131 @@
       </p:grpSp>
       <p:grpSp>
         <p:nvGrpSpPr>
+          <p:cNvPr id="66" name="spin_step_orbit_2"/>
+          <p:cNvGrpSpPr/>
+          <p:nvPr/>
+        </p:nvGrpSpPr>
+        <p:grpSpPr>
+          <a:xfrm>
+            <a:off x="7734300" y="2095500"/>
+            <a:ext cx="2476500" cy="2476500"/>
+            <a:chOff x="7734300" y="2095500"/>
+            <a:chExt cx="2476500" cy="2476500"/>
+          </a:xfrm>
+        </p:grpSpPr>
+        <p:sp>
+          <p:nvSpPr>
+            <p:cNvPr id="62" name="Ellipse 62"/>
+            <p:cNvSpPr/>
+            <p:nvPr/>
+          </p:nvSpPr>
+          <p:spPr>
+            <a:xfrm>
+              <a:off x="7877175" y="2238375"/>
+              <a:ext cx="2190750" cy="2190750"/>
+            </a:xfrm>
+            <a:prstGeom prst="ellipse">
+              <a:avLst/>
+            </a:prstGeom>
+            <a:noFill/>
+            <a:ln w="23812">
+              <a:solidFill>
+                <a:srgbClr val="00F0FF">
+                  <a:alpha val="60000"/>
+                </a:srgbClr>
+              </a:solidFill>
+              <a:custDash>
+                <a:ds d="320000" sp="240000"/>
+              </a:custDash>
+            </a:ln>
+          </p:spPr>
+        </p:sp>
+        <p:sp>
+          <p:nvSpPr>
+            <p:cNvPr id="63" name="Ellipse 63"/>
+            <p:cNvSpPr/>
+            <p:nvPr/>
+          </p:nvSpPr>
+          <p:spPr>
+            <a:xfrm>
+              <a:off x="7734300" y="2095500"/>
+              <a:ext cx="2476500" cy="2476500"/>
+            </a:xfrm>
+            <a:prstGeom prst="ellipse">
+              <a:avLst/>
+            </a:prstGeom>
+            <a:noFill/>
+            <a:ln w="11430">
+              <a:solidFill>
+                <a:srgbClr val="A855F7">
+                  <a:alpha val="40000"/>
+                </a:srgbClr>
+              </a:solidFill>
+              <a:custDash>
+                <a:ds d="333333" sp="666667"/>
+              </a:custDash>
+            </a:ln>
+          </p:spPr>
+        </p:sp>
+        <p:sp>
+          <p:nvSpPr>
+            <p:cNvPr id="64" name="Ellipse 64"/>
+            <p:cNvSpPr/>
+            <p:nvPr/>
+          </p:nvSpPr>
+          <p:spPr>
+            <a:xfrm>
+              <a:off x="10015538" y="3281362"/>
+              <a:ext cx="104775" cy="104775"/>
+            </a:xfrm>
+            <a:prstGeom prst="ellipse">
+              <a:avLst/>
+            </a:prstGeom>
+            <a:solidFill>
+              <a:srgbClr val="EC4899"/>
+            </a:solidFill>
+            <a:ln>
+              <a:noFill/>
+            </a:ln>
+          </p:spPr>
+        </p:sp>
+        <p:sp>
+          <p:nvSpPr>
+            <p:cNvPr id="65" name="Ellipse 65"/>
+            <p:cNvSpPr/>
+            <p:nvPr/>
+          </p:nvSpPr>
+          <p:spPr>
+            <a:xfrm>
+              <a:off x="7834312" y="3290888"/>
+              <a:ext cx="85725" cy="85725"/>
+            </a:xfrm>
+            <a:prstGeom prst="ellipse">
+              <a:avLst/>
+            </a:prstGeom>
+            <a:solidFill>
+              <a:srgbClr val="00F0FF"/>
+            </a:solidFill>
+            <a:ln>
+              <a:noFill/>
+            </a:ln>
+          </p:spPr>
+        </p:sp>
+      </p:grpSp>
+      <p:grpSp>
+        <p:nvGrpSpPr>
           <p:cNvPr id="83" name="step_node_2"/>
           <p:cNvGrpSpPr/>
           <p:nvPr/>
         </p:nvGrpSpPr>
         <p:grpSpPr>
           <a:xfrm>
-            <a:off x="6388100" y="2095500"/>
-            <a:ext cx="5168900" cy="6858000"/>
-            <a:chOff x="6388100" y="2095500"/>
-            <a:chExt cx="5168900" cy="6858000"/>
+            <a:off x="6388100" y="2381250"/>
+            <a:ext cx="5168900" cy="6572250"/>
+            <a:chOff x="6388100" y="2381250"/>
+            <a:chExt cx="5168900" cy="6572250"/>
           </a:xfrm>
         </p:grpSpPr>
-        <p:grpSp>
-          <p:nvGrpSpPr>
-            <p:cNvPr id="66" name="spin_step_orbit_2"/>
-            <p:cNvGrpSpPr/>
-            <p:nvPr/>
-          </p:nvGrpSpPr>
-          <p:grpSpPr>
-            <a:xfrm>
-              <a:off x="7734300" y="2095500"/>
-              <a:ext cx="2476500" cy="2476500"/>
-              <a:chOff x="7734300" y="2095500"/>
-              <a:chExt cx="2476500" cy="2476500"/>
-            </a:xfrm>
-          </p:grpSpPr>
-          <p:sp>
-            <p:nvSpPr>
-              <p:cNvPr id="62" name="Ellipse 62"/>
-              <p:cNvSpPr/>
-              <p:nvPr/>
-            </p:nvSpPr>
-            <p:spPr>
-              <a:xfrm>
-                <a:off x="7877175" y="2238375"/>
-                <a:ext cx="2190750" cy="2190750"/>
-              </a:xfrm>
-              <a:prstGeom prst="ellipse">
-                <a:avLst/>
-              </a:prstGeom>
-              <a:noFill/>
-              <a:ln w="23812">
-                <a:solidFill>
-                  <a:srgbClr val="00F0FF">
-                    <a:alpha val="60000"/>
-                  </a:srgbClr>
-                </a:solidFill>
-                <a:custDash>
-                  <a:ds d="320000" sp="240000"/>
-                </a:custDash>
-              </a:ln>
-            </p:spPr>
-          </p:sp>
-          <p:sp>
-            <p:nvSpPr>
-              <p:cNvPr id="63" name="Ellipse 63"/>
-              <p:cNvSpPr/>
-              <p:nvPr/>
-            </p:nvSpPr>
-            <p:spPr>
-              <a:xfrm>
-                <a:off x="7734300" y="2095500"/>
-                <a:ext cx="2476500" cy="2476500"/>
-              </a:xfrm>
-              <a:prstGeom prst="ellipse">
-                <a:avLst/>
-              </a:prstGeom>
-              <a:noFill/>
-              <a:ln w="11430">
-                <a:solidFill>
-                  <a:srgbClr val="A855F7">
-                    <a:alpha val="40000"/>
-                  </a:srgbClr>
-                </a:solidFill>
-                <a:custDash>
-                  <a:ds d="333333" sp="666667"/>
-                </a:custDash>
-              </a:ln>
-            </p:spPr>
-          </p:sp>
-          <p:sp>
-            <p:nvSpPr>
-              <p:cNvPr id="64" name="Ellipse 64"/>
-              <p:cNvSpPr/>
-              <p:nvPr/>
-            </p:nvSpPr>
-            <p:spPr>
-              <a:xfrm>
-                <a:off x="10015538" y="3281362"/>
-                <a:ext cx="104775" cy="104775"/>
-              </a:xfrm>
-              <a:prstGeom prst="ellipse">
-                <a:avLst/>
-              </a:prstGeom>
-              <a:solidFill>
-                <a:srgbClr val="EC4899"/>
-              </a:solidFill>
-              <a:ln>
-                <a:noFill/>
-              </a:ln>
-            </p:spPr>
-          </p:sp>
-          <p:sp>
-            <p:nvSpPr>
-              <p:cNvPr id="65" name="Ellipse 65"/>
-              <p:cNvSpPr/>
-              <p:nvPr/>
-            </p:nvSpPr>
-            <p:spPr>
-              <a:xfrm>
-                <a:off x="7834312" y="3290888"/>
-                <a:ext cx="85725" cy="85725"/>
-              </a:xfrm>
-              <a:prstGeom prst="ellipse">
-                <a:avLst/>
-              </a:prstGeom>
-              <a:solidFill>
-                <a:srgbClr val="00F0FF"/>
-              </a:solidFill>
-              <a:ln>
-                <a:noFill/>
-              </a:ln>
-            </p:spPr>
-          </p:sp>
-        </p:grpSp>
         <p:sp>
           <p:nvSpPr>
             <p:cNvPr id="67" name="Ellipse 67"/>
@@ -9960,131 +9696,131 @@
       </p:grpSp>
       <p:grpSp>
         <p:nvGrpSpPr>
+          <p:cNvPr id="88" name="spin_step_orbit_3"/>
+          <p:cNvGrpSpPr/>
+          <p:nvPr/>
+        </p:nvGrpSpPr>
+        <p:grpSpPr>
+          <a:xfrm>
+            <a:off x="2222500" y="2095500"/>
+            <a:ext cx="2476500" cy="2476500"/>
+            <a:chOff x="2222500" y="2095500"/>
+            <a:chExt cx="2476500" cy="2476500"/>
+          </a:xfrm>
+        </p:grpSpPr>
+        <p:sp>
+          <p:nvSpPr>
+            <p:cNvPr id="84" name="Ellipse 84"/>
+            <p:cNvSpPr/>
+            <p:nvPr/>
+          </p:nvSpPr>
+          <p:spPr>
+            <a:xfrm>
+              <a:off x="2365375" y="2238375"/>
+              <a:ext cx="2190750" cy="2190750"/>
+            </a:xfrm>
+            <a:prstGeom prst="ellipse">
+              <a:avLst/>
+            </a:prstGeom>
+            <a:noFill/>
+            <a:ln w="23812">
+              <a:solidFill>
+                <a:srgbClr val="00F0FF">
+                  <a:alpha val="60000"/>
+                </a:srgbClr>
+              </a:solidFill>
+              <a:custDash>
+                <a:ds d="320000" sp="240000"/>
+              </a:custDash>
+            </a:ln>
+          </p:spPr>
+        </p:sp>
+        <p:sp>
+          <p:nvSpPr>
+            <p:cNvPr id="85" name="Ellipse 85"/>
+            <p:cNvSpPr/>
+            <p:nvPr/>
+          </p:nvSpPr>
+          <p:spPr>
+            <a:xfrm>
+              <a:off x="2222500" y="2095500"/>
+              <a:ext cx="2476500" cy="2476500"/>
+            </a:xfrm>
+            <a:prstGeom prst="ellipse">
+              <a:avLst/>
+            </a:prstGeom>
+            <a:noFill/>
+            <a:ln w="11430">
+              <a:solidFill>
+                <a:srgbClr val="A855F7">
+                  <a:alpha val="40000"/>
+                </a:srgbClr>
+              </a:solidFill>
+              <a:custDash>
+                <a:ds d="333333" sp="666667"/>
+              </a:custDash>
+            </a:ln>
+          </p:spPr>
+        </p:sp>
+        <p:sp>
+          <p:nvSpPr>
+            <p:cNvPr id="86" name="Ellipse 86"/>
+            <p:cNvSpPr/>
+            <p:nvPr/>
+          </p:nvSpPr>
+          <p:spPr>
+            <a:xfrm>
+              <a:off x="4503738" y="3281362"/>
+              <a:ext cx="104775" cy="104775"/>
+            </a:xfrm>
+            <a:prstGeom prst="ellipse">
+              <a:avLst/>
+            </a:prstGeom>
+            <a:solidFill>
+              <a:srgbClr val="EC4899"/>
+            </a:solidFill>
+            <a:ln>
+              <a:noFill/>
+            </a:ln>
+          </p:spPr>
+        </p:sp>
+        <p:sp>
+          <p:nvSpPr>
+            <p:cNvPr id="87" name="Ellipse 87"/>
+            <p:cNvSpPr/>
+            <p:nvPr/>
+          </p:nvSpPr>
+          <p:spPr>
+            <a:xfrm>
+              <a:off x="2322513" y="3290888"/>
+              <a:ext cx="85725" cy="85725"/>
+            </a:xfrm>
+            <a:prstGeom prst="ellipse">
+              <a:avLst/>
+            </a:prstGeom>
+            <a:solidFill>
+              <a:srgbClr val="00F0FF"/>
+            </a:solidFill>
+            <a:ln>
+              <a:noFill/>
+            </a:ln>
+          </p:spPr>
+        </p:sp>
+      </p:grpSp>
+      <p:grpSp>
+        <p:nvGrpSpPr>
           <p:cNvPr id="106" name="step_node_3"/>
           <p:cNvGrpSpPr/>
           <p:nvPr/>
         </p:nvGrpSpPr>
         <p:grpSpPr>
           <a:xfrm>
-            <a:off x="876300" y="2095500"/>
-            <a:ext cx="5168900" cy="6858000"/>
-            <a:chOff x="876300" y="2095500"/>
-            <a:chExt cx="5168900" cy="6858000"/>
+            <a:off x="876300" y="2381250"/>
+            <a:ext cx="5168900" cy="6572250"/>
+            <a:chOff x="876300" y="2381250"/>
+            <a:chExt cx="5168900" cy="6572250"/>
           </a:xfrm>
         </p:grpSpPr>
-        <p:grpSp>
-          <p:nvGrpSpPr>
-            <p:cNvPr id="88" name="spin_step_orbit_3"/>
-            <p:cNvGrpSpPr/>
-            <p:nvPr/>
-          </p:nvGrpSpPr>
-          <p:grpSpPr>
-            <a:xfrm>
-              <a:off x="2222500" y="2095500"/>
-              <a:ext cx="2476500" cy="2476500"/>
-              <a:chOff x="2222500" y="2095500"/>
-              <a:chExt cx="2476500" cy="2476500"/>
-            </a:xfrm>
-          </p:grpSpPr>
-          <p:sp>
-            <p:nvSpPr>
-              <p:cNvPr id="84" name="Ellipse 84"/>
-              <p:cNvSpPr/>
-              <p:nvPr/>
-            </p:nvSpPr>
-            <p:spPr>
-              <a:xfrm>
-                <a:off x="2365375" y="2238375"/>
-                <a:ext cx="2190750" cy="2190750"/>
-              </a:xfrm>
-              <a:prstGeom prst="ellipse">
-                <a:avLst/>
-              </a:prstGeom>
-              <a:noFill/>
-              <a:ln w="23812">
-                <a:solidFill>
-                  <a:srgbClr val="00F0FF">
-                    <a:alpha val="60000"/>
-                  </a:srgbClr>
-                </a:solidFill>
-                <a:custDash>
-                  <a:ds d="320000" sp="240000"/>
-                </a:custDash>
-              </a:ln>
-            </p:spPr>
-          </p:sp>
-          <p:sp>
-            <p:nvSpPr>
-              <p:cNvPr id="85" name="Ellipse 85"/>
-              <p:cNvSpPr/>
-              <p:nvPr/>
-            </p:nvSpPr>
-            <p:spPr>
-              <a:xfrm>
-                <a:off x="2222500" y="2095500"/>
-                <a:ext cx="2476500" cy="2476500"/>
-              </a:xfrm>
-              <a:prstGeom prst="ellipse">
-                <a:avLst/>
-              </a:prstGeom>
-              <a:noFill/>
-              <a:ln w="11430">
-                <a:solidFill>
-                  <a:srgbClr val="A855F7">
-                    <a:alpha val="40000"/>
-                  </a:srgbClr>
-                </a:solidFill>
-                <a:custDash>
-                  <a:ds d="333333" sp="666667"/>
-                </a:custDash>
-              </a:ln>
-            </p:spPr>
-          </p:sp>
-          <p:sp>
-            <p:nvSpPr>
-              <p:cNvPr id="86" name="Ellipse 86"/>
-              <p:cNvSpPr/>
-              <p:nvPr/>
-            </p:nvSpPr>
-            <p:spPr>
-              <a:xfrm>
-                <a:off x="4503738" y="3281362"/>
-                <a:ext cx="104775" cy="104775"/>
-              </a:xfrm>
-              <a:prstGeom prst="ellipse">
-                <a:avLst/>
-              </a:prstGeom>
-              <a:solidFill>
-                <a:srgbClr val="EC4899"/>
-              </a:solidFill>
-              <a:ln>
-                <a:noFill/>
-              </a:ln>
-            </p:spPr>
-          </p:sp>
-          <p:sp>
-            <p:nvSpPr>
-              <p:cNvPr id="87" name="Ellipse 87"/>
-              <p:cNvSpPr/>
-              <p:nvPr/>
-            </p:nvSpPr>
-            <p:spPr>
-              <a:xfrm>
-                <a:off x="2322513" y="3290888"/>
-                <a:ext cx="85725" cy="85725"/>
-              </a:xfrm>
-              <a:prstGeom prst="ellipse">
-                <a:avLst/>
-              </a:prstGeom>
-              <a:solidFill>
-                <a:srgbClr val="00F0FF"/>
-              </a:solidFill>
-              <a:ln>
-                <a:noFill/>
-              </a:ln>
-            </p:spPr>
-          </p:sp>
-        </p:grpSp>
         <p:sp>
           <p:nvSpPr>
             <p:cNvPr id="89" name="Ellipse 89"/>
@@ -10660,7 +10396,7 @@
   </p:clrMapOvr>
   <mc:AlternateContent xmlns:mc="http://schemas.openxmlformats.org/markup-compatibility/2006">
     <mc:Choice xmlns:p159="http://schemas.microsoft.com/office/powerpoint/2015/09/main" Requires="p159">
-      <p:transition xmlns:p14="http://schemas.microsoft.com/office/powerpoint/2010/main" p14:dur="400">
+      <p:transition xmlns:p14="http://schemas.microsoft.com/office/powerpoint/2010/main" p14:dur="500">
         <p159:morph option="byObject"/>
       </p:transition>
     </mc:Choice>
@@ -10694,7 +10430,7 @@
                             </p:stCondLst>
                             <p:childTnLst>
                               <p:par>
-                                <p:cTn xmlns:p="http://schemas.openxmlformats.org/presentationml/2006/main" id="5" presetID="23" presetClass="entr" presetSubtype="16" fill="hold" grpId="0" nodeType="afterEffect">
+                                <p:cTn xmlns:p="http://schemas.openxmlformats.org/presentationml/2006/main" id="5" presetID="2" presetClass="entr" presetSubtype="4" fill="hold" grpId="0" nodeType="afterEffect">
                                   <p:stCondLst>
                                     <p:cond delay="0"/>
                                   </p:stCondLst>
@@ -10718,47 +10454,47 @@
                                       </p:to>
                                     </p:set>
                                     <p:anim calcmode="lin" valueType="num">
-                                      <p:cBhvr>
-                                        <p:cTn id="7" dur="400" fill="hold"/>
+                                      <p:cBhvr additive="base">
+                                        <p:cTn id="7" dur="500" fill="hold"/>
                                         <p:tgtEl>
                                           <p:spTgt spid="5"/>
                                         </p:tgtEl>
                                         <p:attrNameLst>
-                                          <p:attrName>ppt_w</p:attrName>
+                                          <p:attrName>ppt_x</p:attrName>
                                         </p:attrNameLst>
                                       </p:cBhvr>
                                       <p:tavLst>
                                         <p:tav tm="0">
                                           <p:val>
-                                            <p:fltVal val="0"/>
+                                            <p:strVal val="#ppt_x"/>
                                           </p:val>
                                         </p:tav>
                                         <p:tav tm="100000">
                                           <p:val>
-                                            <p:strVal val="#ppt_w"/>
+                                            <p:strVal val="#ppt_x"/>
                                           </p:val>
                                         </p:tav>
                                       </p:tavLst>
                                     </p:anim>
                                     <p:anim calcmode="lin" valueType="num">
-                                      <p:cBhvr>
-                                        <p:cTn id="8" dur="400" fill="hold"/>
+                                      <p:cBhvr additive="base">
+                                        <p:cTn id="8" dur="500" fill="hold"/>
                                         <p:tgtEl>
                                           <p:spTgt spid="5"/>
                                         </p:tgtEl>
                                         <p:attrNameLst>
-                                          <p:attrName>ppt_h</p:attrName>
+                                          <p:attrName>ppt_y</p:attrName>
                                         </p:attrNameLst>
                                       </p:cBhvr>
                                       <p:tavLst>
                                         <p:tav tm="0">
                                           <p:val>
-                                            <p:fltVal val="0"/>
+                                            <p:strVal val="1+#ppt_h/2"/>
                                           </p:val>
                                         </p:tav>
                                         <p:tav tm="100000">
                                           <p:val>
-                                            <p:strVal val="#ppt_h"/>
+                                            <p:strVal val="#ppt_y"/>
                                           </p:val>
                                         </p:tav>
                                       </p:tavLst>
@@ -10772,110 +10508,26 @@
                         <p:par>
                           <p:cTn id="9" fill="hold">
                             <p:stCondLst>
-                              <p:cond delay="400"/>
+                              <p:cond delay="0"/>
                             </p:stCondLst>
                             <p:childTnLst>
                               <p:par>
-                                <p:cTn xmlns:p="http://schemas.openxmlformats.org/presentationml/2006/main" id="10" presetID="49" presetClass="entr" presetSubtype="0" decel="100000" fill="hold" grpId="0" nodeType="afterEffect">
+                                <p:cTn xmlns:p="http://schemas.openxmlformats.org/presentationml/2006/main" id="10" presetID="8" presetClass="emph" presetSubtype="0" fill="hold" grpId="0" nodeType="withEffect" repeatCount="999000">
                                   <p:stCondLst>
-                                    <p:cond delay="350"/>
+                                    <p:cond delay="0"/>
                                   </p:stCondLst>
                                   <p:childTnLst>
-                                    <p:set>
+                                    <p:animRot by="21600000">
                                       <p:cBhvr>
-                                        <p:cTn id="11" dur="1" fill="hold">
-                                          <p:stCondLst>
-                                            <p:cond delay="0"/>
-                                          </p:stCondLst>
-                                        </p:cTn>
+                                        <p:cTn id="11" dur="8000" fill="hold"/>
                                         <p:tgtEl>
                                           <p:spTgt spid="17"/>
                                         </p:tgtEl>
                                         <p:attrNameLst>
-                                          <p:attrName>style.visibility</p:attrName>
+                                          <p:attrName>r</p:attrName>
                                         </p:attrNameLst>
                                       </p:cBhvr>
-                                      <p:to>
-                                        <p:strVal val="visible"/>
-                                      </p:to>
-                                    </p:set>
-                                    <p:anim calcmode="lin" valueType="num">
-                                      <p:cBhvr>
-                                        <p:cTn id="12" dur="400" fill="hold"/>
-                                        <p:tgtEl>
-                                          <p:spTgt spid="17"/>
-                                        </p:tgtEl>
-                                        <p:attrNameLst>
-                                          <p:attrName>ppt_w</p:attrName>
-                                        </p:attrNameLst>
-                                      </p:cBhvr>
-                                      <p:tavLst>
-                                        <p:tav tm="0">
-                                          <p:val>
-                                            <p:fltVal val="0"/>
-                                          </p:val>
-                                        </p:tav>
-                                        <p:tav tm="100000">
-                                          <p:val>
-                                            <p:strVal val="#ppt_w"/>
-                                          </p:val>
-                                        </p:tav>
-                                      </p:tavLst>
-                                    </p:anim>
-                                    <p:anim calcmode="lin" valueType="num">
-                                      <p:cBhvr>
-                                        <p:cTn id="13" dur="400" fill="hold"/>
-                                        <p:tgtEl>
-                                          <p:spTgt spid="17"/>
-                                        </p:tgtEl>
-                                        <p:attrNameLst>
-                                          <p:attrName>ppt_h</p:attrName>
-                                        </p:attrNameLst>
-                                      </p:cBhvr>
-                                      <p:tavLst>
-                                        <p:tav tm="0">
-                                          <p:val>
-                                            <p:fltVal val="0"/>
-                                          </p:val>
-                                        </p:tav>
-                                        <p:tav tm="100000">
-                                          <p:val>
-                                            <p:strVal val="#ppt_h"/>
-                                          </p:val>
-                                        </p:tav>
-                                      </p:tavLst>
-                                    </p:anim>
-                                    <p:anim calcmode="lin" valueType="num">
-                                      <p:cBhvr>
-                                        <p:cTn id="14" dur="400" fill="hold"/>
-                                        <p:tgtEl>
-                                          <p:spTgt spid="17"/>
-                                        </p:tgtEl>
-                                        <p:attrNameLst>
-                                          <p:attrName>style.rotation</p:attrName>
-                                        </p:attrNameLst>
-                                      </p:cBhvr>
-                                      <p:tavLst>
-                                        <p:tav tm="0">
-                                          <p:val>
-                                            <p:fltVal val="360"/>
-                                          </p:val>
-                                        </p:tav>
-                                        <p:tav tm="100000">
-                                          <p:val>
-                                            <p:fltVal val="0"/>
-                                          </p:val>
-                                        </p:tav>
-                                      </p:tavLst>
-                                    </p:anim>
-                                    <p:animEffect transition="in" filter="fade">
-                                      <p:cBhvr>
-                                        <p:cTn id="15" dur="400"/>
-                                        <p:tgtEl>
-                                          <p:spTgt spid="17"/>
-                                        </p:tgtEl>
-                                      </p:cBhvr>
-                                    </p:animEffect>
+                                    </p:animRot>
                                   </p:childTnLst>
                                 </p:cTn>
                               </p:par>
@@ -10883,112 +10535,28 @@
                           </p:cTn>
                         </p:par>
                         <p:par>
-                          <p:cTn id="16" fill="hold">
+                          <p:cTn id="12" fill="hold">
                             <p:stCondLst>
-                              <p:cond delay="1150"/>
+                              <p:cond delay="0"/>
                             </p:stCondLst>
                             <p:childTnLst>
                               <p:par>
-                                <p:cTn xmlns:p="http://schemas.openxmlformats.org/presentationml/2006/main" id="17" presetID="49" presetClass="entr" presetSubtype="0" decel="100000" fill="hold" grpId="0" nodeType="afterEffect">
+                                <p:cTn xmlns:p="http://schemas.openxmlformats.org/presentationml/2006/main" id="13" presetID="8" presetClass="emph" presetSubtype="0" fill="hold" grpId="0" nodeType="withEffect" repeatCount="999000">
                                   <p:stCondLst>
-                                    <p:cond delay="350"/>
+                                    <p:cond delay="0"/>
                                   </p:stCondLst>
                                   <p:childTnLst>
-                                    <p:set>
+                                    <p:animRot by="21600000">
                                       <p:cBhvr>
-                                        <p:cTn id="18" dur="1" fill="hold">
-                                          <p:stCondLst>
-                                            <p:cond delay="0"/>
-                                          </p:stCondLst>
-                                        </p:cTn>
+                                        <p:cTn id="14" dur="12000" fill="hold"/>
                                         <p:tgtEl>
                                           <p:spTgt spid="34"/>
                                         </p:tgtEl>
                                         <p:attrNameLst>
-                                          <p:attrName>style.visibility</p:attrName>
+                                          <p:attrName>r</p:attrName>
                                         </p:attrNameLst>
                                       </p:cBhvr>
-                                      <p:to>
-                                        <p:strVal val="visible"/>
-                                      </p:to>
-                                    </p:set>
-                                    <p:anim calcmode="lin" valueType="num">
-                                      <p:cBhvr>
-                                        <p:cTn id="19" dur="400" fill="hold"/>
-                                        <p:tgtEl>
-                                          <p:spTgt spid="34"/>
-                                        </p:tgtEl>
-                                        <p:attrNameLst>
-                                          <p:attrName>ppt_w</p:attrName>
-                                        </p:attrNameLst>
-                                      </p:cBhvr>
-                                      <p:tavLst>
-                                        <p:tav tm="0">
-                                          <p:val>
-                                            <p:fltVal val="0"/>
-                                          </p:val>
-                                        </p:tav>
-                                        <p:tav tm="100000">
-                                          <p:val>
-                                            <p:strVal val="#ppt_w"/>
-                                          </p:val>
-                                        </p:tav>
-                                      </p:tavLst>
-                                    </p:anim>
-                                    <p:anim calcmode="lin" valueType="num">
-                                      <p:cBhvr>
-                                        <p:cTn id="20" dur="400" fill="hold"/>
-                                        <p:tgtEl>
-                                          <p:spTgt spid="34"/>
-                                        </p:tgtEl>
-                                        <p:attrNameLst>
-                                          <p:attrName>ppt_h</p:attrName>
-                                        </p:attrNameLst>
-                                      </p:cBhvr>
-                                      <p:tavLst>
-                                        <p:tav tm="0">
-                                          <p:val>
-                                            <p:fltVal val="0"/>
-                                          </p:val>
-                                        </p:tav>
-                                        <p:tav tm="100000">
-                                          <p:val>
-                                            <p:strVal val="#ppt_h"/>
-                                          </p:val>
-                                        </p:tav>
-                                      </p:tavLst>
-                                    </p:anim>
-                                    <p:anim calcmode="lin" valueType="num">
-                                      <p:cBhvr>
-                                        <p:cTn id="21" dur="400" fill="hold"/>
-                                        <p:tgtEl>
-                                          <p:spTgt spid="34"/>
-                                        </p:tgtEl>
-                                        <p:attrNameLst>
-                                          <p:attrName>style.rotation</p:attrName>
-                                        </p:attrNameLst>
-                                      </p:cBhvr>
-                                      <p:tavLst>
-                                        <p:tav tm="0">
-                                          <p:val>
-                                            <p:fltVal val="360"/>
-                                          </p:val>
-                                        </p:tav>
-                                        <p:tav tm="100000">
-                                          <p:val>
-                                            <p:fltVal val="0"/>
-                                          </p:val>
-                                        </p:tav>
-                                      </p:tavLst>
-                                    </p:anim>
-                                    <p:animEffect transition="in" filter="fade">
-                                      <p:cBhvr>
-                                        <p:cTn id="22" dur="400"/>
-                                        <p:tgtEl>
-                                          <p:spTgt spid="34"/>
-                                        </p:tgtEl>
-                                      </p:cBhvr>
-                                    </p:animEffect>
+                                    </p:animRot>
                                   </p:childTnLst>
                                 </p:cTn>
                               </p:par>
@@ -10996,20 +10564,49 @@
                           </p:cTn>
                         </p:par>
                         <p:par>
-                          <p:cTn id="23" fill="hold">
+                          <p:cTn id="15" fill="hold">
                             <p:stCondLst>
-                              <p:cond delay="1900"/>
+                              <p:cond delay="0"/>
                             </p:stCondLst>
                             <p:childTnLst>
                               <p:par>
-                                <p:cTn xmlns:p="http://schemas.openxmlformats.org/presentationml/2006/main" id="24" presetID="2" presetClass="entr" presetSubtype="4" fill="hold" grpId="0" nodeType="afterEffect">
+                                <p:cTn xmlns:p="http://schemas.openxmlformats.org/presentationml/2006/main" id="16" presetID="8" presetClass="emph" presetSubtype="0" fill="hold" grpId="0" nodeType="withEffect" repeatCount="999000">
+                                  <p:stCondLst>
+                                    <p:cond delay="0"/>
+                                  </p:stCondLst>
+                                  <p:childTnLst>
+                                    <p:animRot by="21600000">
+                                      <p:cBhvr>
+                                        <p:cTn id="17" dur="8000" fill="hold"/>
+                                        <p:tgtEl>
+                                          <p:spTgt spid="44"/>
+                                        </p:tgtEl>
+                                        <p:attrNameLst>
+                                          <p:attrName>r</p:attrName>
+                                        </p:attrNameLst>
+                                      </p:cBhvr>
+                                    </p:animRot>
+                                  </p:childTnLst>
+                                </p:cTn>
+                              </p:par>
+                            </p:childTnLst>
+                          </p:cTn>
+                        </p:par>
+                        <p:par>
+                          <p:cTn id="18" fill="hold">
+                            <p:stCondLst>
+                              <p:cond delay="0"/>
+                            </p:stCondLst>
+                            <p:childTnLst>
+                              <p:par>
+                                <p:cTn xmlns:p="http://schemas.openxmlformats.org/presentationml/2006/main" id="19" presetID="2" presetClass="entr" presetSubtype="4" fill="hold" grpId="0" nodeType="afterEffect">
                                   <p:stCondLst>
                                     <p:cond delay="350"/>
                                   </p:stCondLst>
                                   <p:childTnLst>
                                     <p:set>
                                       <p:cBhvr>
-                                        <p:cTn id="25" dur="1" fill="hold">
+                                        <p:cTn id="20" dur="1" fill="hold">
                                           <p:stCondLst>
                                             <p:cond delay="0"/>
                                           </p:stCondLst>
@@ -11027,7 +10624,7 @@
                                     </p:set>
                                     <p:anim calcmode="lin" valueType="num">
                                       <p:cBhvr additive="base">
-                                        <p:cTn id="26" dur="400" fill="hold"/>
+                                        <p:cTn id="21" dur="500" fill="hold"/>
                                         <p:tgtEl>
                                           <p:spTgt spid="61"/>
                                         </p:tgtEl>
@@ -11050,7 +10647,7 @@
                                     </p:anim>
                                     <p:anim calcmode="lin" valueType="num">
                                       <p:cBhvr additive="base">
-                                        <p:cTn id="27" dur="400" fill="hold"/>
+                                        <p:cTn id="22" dur="500" fill="hold"/>
                                         <p:tgtEl>
                                           <p:spTgt spid="61"/>
                                         </p:tgtEl>
@@ -11078,20 +10675,49 @@
                           </p:cTn>
                         </p:par>
                         <p:par>
-                          <p:cTn id="28" fill="hold">
+                          <p:cTn id="23" fill="hold">
                             <p:stCondLst>
-                              <p:cond delay="2650"/>
+                              <p:cond delay="350"/>
                             </p:stCondLst>
                             <p:childTnLst>
                               <p:par>
-                                <p:cTn xmlns:p="http://schemas.openxmlformats.org/presentationml/2006/main" id="29" presetID="23" presetClass="entr" presetSubtype="16" fill="hold" grpId="0" nodeType="afterEffect">
+                                <p:cTn xmlns:p="http://schemas.openxmlformats.org/presentationml/2006/main" id="24" presetID="8" presetClass="emph" presetSubtype="0" fill="hold" grpId="0" nodeType="withEffect" repeatCount="999000">
+                                  <p:stCondLst>
+                                    <p:cond delay="0"/>
+                                  </p:stCondLst>
+                                  <p:childTnLst>
+                                    <p:animRot by="21600000">
+                                      <p:cBhvr>
+                                        <p:cTn id="25" dur="8000" fill="hold"/>
+                                        <p:tgtEl>
+                                          <p:spTgt spid="66"/>
+                                        </p:tgtEl>
+                                        <p:attrNameLst>
+                                          <p:attrName>r</p:attrName>
+                                        </p:attrNameLst>
+                                      </p:cBhvr>
+                                    </p:animRot>
+                                  </p:childTnLst>
+                                </p:cTn>
+                              </p:par>
+                            </p:childTnLst>
+                          </p:cTn>
+                        </p:par>
+                        <p:par>
+                          <p:cTn id="26" fill="hold">
+                            <p:stCondLst>
+                              <p:cond delay="350"/>
+                            </p:stCondLst>
+                            <p:childTnLst>
+                              <p:par>
+                                <p:cTn xmlns:p="http://schemas.openxmlformats.org/presentationml/2006/main" id="27" presetID="10" presetClass="entr" presetSubtype="0" fill="hold" grpId="0" nodeType="afterEffect">
                                   <p:stCondLst>
                                     <p:cond delay="350"/>
                                   </p:stCondLst>
                                   <p:childTnLst>
                                     <p:set>
                                       <p:cBhvr>
-                                        <p:cTn id="30" dur="1" fill="hold">
+                                        <p:cTn id="28" dur="1" fill="hold">
                                           <p:stCondLst>
                                             <p:cond delay="0"/>
                                           </p:stCondLst>
@@ -11107,52 +10733,43 @@
                                         <p:strVal val="visible"/>
                                       </p:to>
                                     </p:set>
-                                    <p:anim calcmode="lin" valueType="num">
+                                    <p:animEffect transition="in" filter="fade">
                                       <p:cBhvr>
-                                        <p:cTn id="31" dur="400" fill="hold"/>
+                                        <p:cTn id="29" dur="500"/>
                                         <p:tgtEl>
                                           <p:spTgt spid="83"/>
                                         </p:tgtEl>
+                                      </p:cBhvr>
+                                    </p:animEffect>
+                                  </p:childTnLst>
+                                </p:cTn>
+                              </p:par>
+                            </p:childTnLst>
+                          </p:cTn>
+                        </p:par>
+                        <p:par>
+                          <p:cTn id="30" fill="hold">
+                            <p:stCondLst>
+                              <p:cond delay="700"/>
+                            </p:stCondLst>
+                            <p:childTnLst>
+                              <p:par>
+                                <p:cTn xmlns:p="http://schemas.openxmlformats.org/presentationml/2006/main" id="31" presetID="8" presetClass="emph" presetSubtype="0" fill="hold" grpId="0" nodeType="withEffect" repeatCount="999000">
+                                  <p:stCondLst>
+                                    <p:cond delay="0"/>
+                                  </p:stCondLst>
+                                  <p:childTnLst>
+                                    <p:animRot by="21600000">
+                                      <p:cBhvr>
+                                        <p:cTn id="32" dur="8000" fill="hold"/>
+                                        <p:tgtEl>
+                                          <p:spTgt spid="88"/>
+                                        </p:tgtEl>
                                         <p:attrNameLst>
-                                          <p:attrName>ppt_w</p:attrName>
+                                          <p:attrName>r</p:attrName>
                                         </p:attrNameLst>
                                       </p:cBhvr>
-                                      <p:tavLst>
-                                        <p:tav tm="0">
-                                          <p:val>
-                                            <p:fltVal val="0"/>
-                                          </p:val>
-                                        </p:tav>
-                                        <p:tav tm="100000">
-                                          <p:val>
-                                            <p:strVal val="#ppt_w"/>
-                                          </p:val>
-                                        </p:tav>
-                                      </p:tavLst>
-                                    </p:anim>
-                                    <p:anim calcmode="lin" valueType="num">
-                                      <p:cBhvr>
-                                        <p:cTn id="32" dur="400" fill="hold"/>
-                                        <p:tgtEl>
-                                          <p:spTgt spid="83"/>
-                                        </p:tgtEl>
-                                        <p:attrNameLst>
-                                          <p:attrName>ppt_h</p:attrName>
-                                        </p:attrNameLst>
-                                      </p:cBhvr>
-                                      <p:tavLst>
-                                        <p:tav tm="0">
-                                          <p:val>
-                                            <p:fltVal val="0"/>
-                                          </p:val>
-                                        </p:tav>
-                                        <p:tav tm="100000">
-                                          <p:val>
-                                            <p:strVal val="#ppt_h"/>
-                                          </p:val>
-                                        </p:tav>
-                                      </p:tavLst>
-                                    </p:anim>
+                                    </p:animRot>
                                   </p:childTnLst>
                                 </p:cTn>
                               </p:par>
@@ -11162,11 +10779,11 @@
                         <p:par>
                           <p:cTn id="33" fill="hold">
                             <p:stCondLst>
-                              <p:cond delay="3400"/>
+                              <p:cond delay="700"/>
                             </p:stCondLst>
                             <p:childTnLst>
                               <p:par>
-                                <p:cTn xmlns:p="http://schemas.openxmlformats.org/presentationml/2006/main" id="34" presetID="10" presetClass="entr" presetSubtype="0" fill="hold" grpId="0" nodeType="afterEffect">
+                                <p:cTn xmlns:p="http://schemas.openxmlformats.org/presentationml/2006/main" id="34" presetID="2" presetClass="entr" presetSubtype="4" fill="hold" grpId="0" nodeType="afterEffect">
                                   <p:stCondLst>
                                     <p:cond delay="350"/>
                                   </p:stCondLst>
@@ -11189,14 +10806,52 @@
                                         <p:strVal val="visible"/>
                                       </p:to>
                                     </p:set>
-                                    <p:animEffect transition="in" filter="fade">
-                                      <p:cBhvr>
-                                        <p:cTn id="36" dur="400"/>
+                                    <p:anim calcmode="lin" valueType="num">
+                                      <p:cBhvr additive="base">
+                                        <p:cTn id="36" dur="500" fill="hold"/>
                                         <p:tgtEl>
                                           <p:spTgt spid="106"/>
                                         </p:tgtEl>
+                                        <p:attrNameLst>
+                                          <p:attrName>ppt_x</p:attrName>
+                                        </p:attrNameLst>
                                       </p:cBhvr>
-                                    </p:animEffect>
+                                      <p:tavLst>
+                                        <p:tav tm="0">
+                                          <p:val>
+                                            <p:strVal val="#ppt_x"/>
+                                          </p:val>
+                                        </p:tav>
+                                        <p:tav tm="100000">
+                                          <p:val>
+                                            <p:strVal val="#ppt_x"/>
+                                          </p:val>
+                                        </p:tav>
+                                      </p:tavLst>
+                                    </p:anim>
+                                    <p:anim calcmode="lin" valueType="num">
+                                      <p:cBhvr additive="base">
+                                        <p:cTn id="37" dur="500" fill="hold"/>
+                                        <p:tgtEl>
+                                          <p:spTgt spid="106"/>
+                                        </p:tgtEl>
+                                        <p:attrNameLst>
+                                          <p:attrName>ppt_y</p:attrName>
+                                        </p:attrNameLst>
+                                      </p:cBhvr>
+                                      <p:tavLst>
+                                        <p:tav tm="0">
+                                          <p:val>
+                                            <p:strVal val="1+#ppt_h/2"/>
+                                          </p:val>
+                                        </p:tav>
+                                        <p:tav tm="100000">
+                                          <p:val>
+                                            <p:strVal val="#ppt_y"/>
+                                          </p:val>
+                                        </p:tav>
+                                      </p:tavLst>
+                                    </p:anim>
                                   </p:childTnLst>
                                 </p:cTn>
                               </p:par>
@@ -12326,6 +11981,95 @@
       </p:grpSp>
       <p:grpSp>
         <p:nvGrpSpPr>
+          <p:cNvPr id="45" name="spin_kpi_dial_1"/>
+          <p:cNvGrpSpPr/>
+          <p:nvPr/>
+        </p:nvGrpSpPr>
+        <p:grpSpPr>
+          <a:xfrm>
+            <a:off x="15449550" y="3038475"/>
+            <a:ext cx="1524000" cy="1485900"/>
+            <a:chOff x="15449550" y="3038475"/>
+            <a:chExt cx="1524000" cy="1485900"/>
+          </a:xfrm>
+        </p:grpSpPr>
+        <p:sp>
+          <p:nvSpPr>
+            <p:cNvPr id="42" name="Ellipse 42"/>
+            <p:cNvSpPr/>
+            <p:nvPr/>
+          </p:nvSpPr>
+          <p:spPr>
+            <a:xfrm>
+              <a:off x="15449550" y="3038475"/>
+              <a:ext cx="1485900" cy="1485900"/>
+            </a:xfrm>
+            <a:prstGeom prst="ellipse">
+              <a:avLst/>
+            </a:prstGeom>
+            <a:noFill/>
+            <a:ln w="17145">
+              <a:solidFill>
+                <a:srgbClr val="A855F7">
+                  <a:alpha val="50000"/>
+                </a:srgbClr>
+              </a:solidFill>
+              <a:custDash>
+                <a:ds d="222222" sp="333333"/>
+              </a:custDash>
+            </a:ln>
+          </p:spPr>
+        </p:sp>
+        <p:sp>
+          <p:nvSpPr>
+            <p:cNvPr id="43" name="Ellipse 43"/>
+            <p:cNvSpPr/>
+            <p:nvPr/>
+          </p:nvSpPr>
+          <p:spPr>
+            <a:xfrm>
+              <a:off x="15582900" y="3171825"/>
+              <a:ext cx="1219200" cy="1219200"/>
+            </a:xfrm>
+            <a:prstGeom prst="ellipse">
+              <a:avLst/>
+            </a:prstGeom>
+            <a:noFill/>
+            <a:ln w="57150" cap="rnd">
+              <a:solidFill>
+                <a:srgbClr val="00F0FF"/>
+              </a:solidFill>
+              <a:custDash>
+                <a:ds d="4333333" sp="2333333"/>
+              </a:custDash>
+            </a:ln>
+          </p:spPr>
+        </p:sp>
+        <p:sp>
+          <p:nvSpPr>
+            <p:cNvPr id="44" name="Ellipse 44"/>
+            <p:cNvSpPr/>
+            <p:nvPr/>
+          </p:nvSpPr>
+          <p:spPr>
+            <a:xfrm>
+              <a:off x="16897350" y="3743325"/>
+              <a:ext cx="76200" cy="76200"/>
+            </a:xfrm>
+            <a:prstGeom prst="ellipse">
+              <a:avLst/>
+            </a:prstGeom>
+            <a:solidFill>
+              <a:srgbClr val="EC4899"/>
+            </a:solidFill>
+            <a:ln>
+              <a:noFill/>
+            </a:ln>
+          </p:spPr>
+        </p:sp>
+      </p:grpSp>
+      <p:grpSp>
+        <p:nvGrpSpPr>
           <p:cNvPr id="53" name="kpi_1"/>
           <p:cNvGrpSpPr/>
           <p:nvPr/>
@@ -12340,7 +12084,7 @@
         </p:grpSpPr>
         <p:sp>
           <p:nvSpPr>
-            <p:cNvPr id="42" name="Rectangle 42"/>
+            <p:cNvPr id="46" name="Rectangle 46"/>
             <p:cNvSpPr/>
             <p:nvPr/>
           </p:nvSpPr>
@@ -12364,95 +12108,6 @@
             </a:ln>
           </p:spPr>
         </p:sp>
-        <p:grpSp>
-          <p:nvGrpSpPr>
-            <p:cNvPr id="46" name="spin_kpi_dial_1"/>
-            <p:cNvGrpSpPr/>
-            <p:nvPr/>
-          </p:nvGrpSpPr>
-          <p:grpSpPr>
-            <a:xfrm>
-              <a:off x="15449550" y="3038475"/>
-              <a:ext cx="1524000" cy="1485900"/>
-              <a:chOff x="15449550" y="3038475"/>
-              <a:chExt cx="1524000" cy="1485900"/>
-            </a:xfrm>
-          </p:grpSpPr>
-          <p:sp>
-            <p:nvSpPr>
-              <p:cNvPr id="43" name="Ellipse 43"/>
-              <p:cNvSpPr/>
-              <p:nvPr/>
-            </p:nvSpPr>
-            <p:spPr>
-              <a:xfrm>
-                <a:off x="15449550" y="3038475"/>
-                <a:ext cx="1485900" cy="1485900"/>
-              </a:xfrm>
-              <a:prstGeom prst="ellipse">
-                <a:avLst/>
-              </a:prstGeom>
-              <a:noFill/>
-              <a:ln w="17145">
-                <a:solidFill>
-                  <a:srgbClr val="A855F7">
-                    <a:alpha val="50000"/>
-                  </a:srgbClr>
-                </a:solidFill>
-                <a:custDash>
-                  <a:ds d="222222" sp="333333"/>
-                </a:custDash>
-              </a:ln>
-            </p:spPr>
-          </p:sp>
-          <p:sp>
-            <p:nvSpPr>
-              <p:cNvPr id="44" name="Ellipse 44"/>
-              <p:cNvSpPr/>
-              <p:nvPr/>
-            </p:nvSpPr>
-            <p:spPr>
-              <a:xfrm>
-                <a:off x="15582900" y="3171825"/>
-                <a:ext cx="1219200" cy="1219200"/>
-              </a:xfrm>
-              <a:prstGeom prst="ellipse">
-                <a:avLst/>
-              </a:prstGeom>
-              <a:noFill/>
-              <a:ln w="57150" cap="rnd">
-                <a:solidFill>
-                  <a:srgbClr val="00F0FF"/>
-                </a:solidFill>
-                <a:custDash>
-                  <a:ds d="4333333" sp="2333333"/>
-                </a:custDash>
-              </a:ln>
-            </p:spPr>
-          </p:sp>
-          <p:sp>
-            <p:nvSpPr>
-              <p:cNvPr id="45" name="Ellipse 45"/>
-              <p:cNvSpPr/>
-              <p:nvPr/>
-            </p:nvSpPr>
-            <p:spPr>
-              <a:xfrm>
-                <a:off x="16897350" y="3743325"/>
-                <a:ext cx="76200" cy="76200"/>
-              </a:xfrm>
-              <a:prstGeom prst="ellipse">
-                <a:avLst/>
-              </a:prstGeom>
-              <a:solidFill>
-                <a:srgbClr val="EC4899"/>
-              </a:solidFill>
-              <a:ln>
-                <a:noFill/>
-              </a:ln>
-            </p:spPr>
-          </p:sp>
-        </p:grpSp>
         <p:sp>
           <p:nvSpPr>
             <p:cNvPr id="47" name="Ellipse 47"/>
@@ -12669,6 +12324,95 @@
       </p:grpSp>
       <p:grpSp>
         <p:nvGrpSpPr>
+          <p:cNvPr id="57" name="spin_kpi_dial_2"/>
+          <p:cNvGrpSpPr/>
+          <p:nvPr/>
+        </p:nvGrpSpPr>
+        <p:grpSpPr>
+          <a:xfrm>
+            <a:off x="15449550" y="6524625"/>
+            <a:ext cx="1524000" cy="1485900"/>
+            <a:chOff x="15449550" y="6524625"/>
+            <a:chExt cx="1524000" cy="1485900"/>
+          </a:xfrm>
+        </p:grpSpPr>
+        <p:sp>
+          <p:nvSpPr>
+            <p:cNvPr id="54" name="Ellipse 54"/>
+            <p:cNvSpPr/>
+            <p:nvPr/>
+          </p:nvSpPr>
+          <p:spPr>
+            <a:xfrm>
+              <a:off x="15449550" y="6524625"/>
+              <a:ext cx="1485900" cy="1485900"/>
+            </a:xfrm>
+            <a:prstGeom prst="ellipse">
+              <a:avLst/>
+            </a:prstGeom>
+            <a:noFill/>
+            <a:ln w="17145">
+              <a:solidFill>
+                <a:srgbClr val="A855F7">
+                  <a:alpha val="50000"/>
+                </a:srgbClr>
+              </a:solidFill>
+              <a:custDash>
+                <a:ds d="222222" sp="333333"/>
+              </a:custDash>
+            </a:ln>
+          </p:spPr>
+        </p:sp>
+        <p:sp>
+          <p:nvSpPr>
+            <p:cNvPr id="55" name="Ellipse 55"/>
+            <p:cNvSpPr/>
+            <p:nvPr/>
+          </p:nvSpPr>
+          <p:spPr>
+            <a:xfrm>
+              <a:off x="15582900" y="6657975"/>
+              <a:ext cx="1219200" cy="1219200"/>
+            </a:xfrm>
+            <a:prstGeom prst="ellipse">
+              <a:avLst/>
+            </a:prstGeom>
+            <a:noFill/>
+            <a:ln w="57150" cap="rnd">
+              <a:solidFill>
+                <a:srgbClr val="00F0FF"/>
+              </a:solidFill>
+              <a:custDash>
+                <a:ds d="4333333" sp="2333333"/>
+              </a:custDash>
+            </a:ln>
+          </p:spPr>
+        </p:sp>
+        <p:sp>
+          <p:nvSpPr>
+            <p:cNvPr id="56" name="Ellipse 56"/>
+            <p:cNvSpPr/>
+            <p:nvPr/>
+          </p:nvSpPr>
+          <p:spPr>
+            <a:xfrm>
+              <a:off x="16897350" y="7229475"/>
+              <a:ext cx="76200" cy="76200"/>
+            </a:xfrm>
+            <a:prstGeom prst="ellipse">
+              <a:avLst/>
+            </a:prstGeom>
+            <a:solidFill>
+              <a:srgbClr val="EC4899"/>
+            </a:solidFill>
+            <a:ln>
+              <a:noFill/>
+            </a:ln>
+          </p:spPr>
+        </p:sp>
+      </p:grpSp>
+      <p:grpSp>
+        <p:nvGrpSpPr>
           <p:cNvPr id="65" name="kpi_2"/>
           <p:cNvGrpSpPr/>
           <p:nvPr/>
@@ -12683,7 +12427,7 @@
         </p:grpSpPr>
         <p:sp>
           <p:nvSpPr>
-            <p:cNvPr id="54" name="Rectangle 54"/>
+            <p:cNvPr id="58" name="Rectangle 58"/>
             <p:cNvSpPr/>
             <p:nvPr/>
           </p:nvSpPr>
@@ -12707,95 +12451,6 @@
             </a:ln>
           </p:spPr>
         </p:sp>
-        <p:grpSp>
-          <p:nvGrpSpPr>
-            <p:cNvPr id="58" name="spin_kpi_dial_2"/>
-            <p:cNvGrpSpPr/>
-            <p:nvPr/>
-          </p:nvGrpSpPr>
-          <p:grpSpPr>
-            <a:xfrm>
-              <a:off x="15449550" y="6524625"/>
-              <a:ext cx="1524000" cy="1485900"/>
-              <a:chOff x="15449550" y="6524625"/>
-              <a:chExt cx="1524000" cy="1485900"/>
-            </a:xfrm>
-          </p:grpSpPr>
-          <p:sp>
-            <p:nvSpPr>
-              <p:cNvPr id="55" name="Ellipse 55"/>
-              <p:cNvSpPr/>
-              <p:nvPr/>
-            </p:nvSpPr>
-            <p:spPr>
-              <a:xfrm>
-                <a:off x="15449550" y="6524625"/>
-                <a:ext cx="1485900" cy="1485900"/>
-              </a:xfrm>
-              <a:prstGeom prst="ellipse">
-                <a:avLst/>
-              </a:prstGeom>
-              <a:noFill/>
-              <a:ln w="17145">
-                <a:solidFill>
-                  <a:srgbClr val="A855F7">
-                    <a:alpha val="50000"/>
-                  </a:srgbClr>
-                </a:solidFill>
-                <a:custDash>
-                  <a:ds d="222222" sp="333333"/>
-                </a:custDash>
-              </a:ln>
-            </p:spPr>
-          </p:sp>
-          <p:sp>
-            <p:nvSpPr>
-              <p:cNvPr id="56" name="Ellipse 56"/>
-              <p:cNvSpPr/>
-              <p:nvPr/>
-            </p:nvSpPr>
-            <p:spPr>
-              <a:xfrm>
-                <a:off x="15582900" y="6657975"/>
-                <a:ext cx="1219200" cy="1219200"/>
-              </a:xfrm>
-              <a:prstGeom prst="ellipse">
-                <a:avLst/>
-              </a:prstGeom>
-              <a:noFill/>
-              <a:ln w="57150" cap="rnd">
-                <a:solidFill>
-                  <a:srgbClr val="00F0FF"/>
-                </a:solidFill>
-                <a:custDash>
-                  <a:ds d="4333333" sp="2333333"/>
-                </a:custDash>
-              </a:ln>
-            </p:spPr>
-          </p:sp>
-          <p:sp>
-            <p:nvSpPr>
-              <p:cNvPr id="57" name="Ellipse 57"/>
-              <p:cNvSpPr/>
-              <p:nvPr/>
-            </p:nvSpPr>
-            <p:spPr>
-              <a:xfrm>
-                <a:off x="16897350" y="7229475"/>
-                <a:ext cx="76200" cy="76200"/>
-              </a:xfrm>
-              <a:prstGeom prst="ellipse">
-                <a:avLst/>
-              </a:prstGeom>
-              <a:solidFill>
-                <a:srgbClr val="EC4899"/>
-              </a:solidFill>
-              <a:ln>
-                <a:noFill/>
-              </a:ln>
-            </p:spPr>
-          </p:sp>
-        </p:grpSp>
         <p:sp>
           <p:nvSpPr>
             <p:cNvPr id="59" name="Ellipse 59"/>
@@ -13017,7 +12672,7 @@
   </p:clrMapOvr>
   <mc:AlternateContent xmlns:mc="http://schemas.openxmlformats.org/markup-compatibility/2006">
     <mc:Choice xmlns:p159="http://schemas.microsoft.com/office/powerpoint/2015/09/main" Requires="p159">
-      <p:transition xmlns:p14="http://schemas.microsoft.com/office/powerpoint/2010/main" p14:dur="400">
+      <p:transition xmlns:p14="http://schemas.microsoft.com/office/powerpoint/2010/main" p14:dur="500">
         <p159:morph option="byObject"/>
       </p:transition>
     </mc:Choice>
@@ -13051,7 +12706,7 @@
                             </p:stCondLst>
                             <p:childTnLst>
                               <p:par>
-                                <p:cTn xmlns:p="http://schemas.openxmlformats.org/presentationml/2006/main" id="5" presetID="22" presetClass="entr" presetSubtype="4" fill="hold" grpId="0" nodeType="afterEffect">
+                                <p:cTn xmlns:p="http://schemas.openxmlformats.org/presentationml/2006/main" id="5" presetID="23" presetClass="entr" presetSubtype="16" fill="hold" grpId="0" nodeType="afterEffect">
                                   <p:stCondLst>
                                     <p:cond delay="0"/>
                                   </p:stCondLst>
@@ -13074,55 +12729,11 @@
                                         <p:strVal val="visible"/>
                                       </p:to>
                                     </p:set>
-                                    <p:animEffect transition="in" filter="wipe(down)">
+                                    <p:anim calcmode="lin" valueType="num">
                                       <p:cBhvr>
-                                        <p:cTn id="7" dur="400"/>
+                                        <p:cTn id="7" dur="500" fill="hold"/>
                                         <p:tgtEl>
                                           <p:spTgt spid="5"/>
-                                        </p:tgtEl>
-                                      </p:cBhvr>
-                                    </p:animEffect>
-                                  </p:childTnLst>
-                                </p:cTn>
-                              </p:par>
-                            </p:childTnLst>
-                          </p:cTn>
-                        </p:par>
-                        <p:par>
-                          <p:cTn id="8" fill="hold">
-                            <p:stCondLst>
-                              <p:cond delay="400"/>
-                            </p:stCondLst>
-                            <p:childTnLst>
-                              <p:par>
-                                <p:cTn xmlns:p="http://schemas.openxmlformats.org/presentationml/2006/main" id="9" presetID="49" presetClass="entr" presetSubtype="0" decel="100000" fill="hold" grpId="0" nodeType="afterEffect">
-                                  <p:stCondLst>
-                                    <p:cond delay="350"/>
-                                  </p:stCondLst>
-                                  <p:childTnLst>
-                                    <p:set>
-                                      <p:cBhvr>
-                                        <p:cTn id="10" dur="1" fill="hold">
-                                          <p:stCondLst>
-                                            <p:cond delay="0"/>
-                                          </p:stCondLst>
-                                        </p:cTn>
-                                        <p:tgtEl>
-                                          <p:spTgt spid="17"/>
-                                        </p:tgtEl>
-                                        <p:attrNameLst>
-                                          <p:attrName>style.visibility</p:attrName>
-                                        </p:attrNameLst>
-                                      </p:cBhvr>
-                                      <p:to>
-                                        <p:strVal val="visible"/>
-                                      </p:to>
-                                    </p:set>
-                                    <p:anim calcmode="lin" valueType="num">
-                                      <p:cBhvr>
-                                        <p:cTn id="11" dur="400" fill="hold"/>
-                                        <p:tgtEl>
-                                          <p:spTgt spid="17"/>
                                         </p:tgtEl>
                                         <p:attrNameLst>
                                           <p:attrName>ppt_w</p:attrName>
@@ -13143,9 +12754,9 @@
                                     </p:anim>
                                     <p:anim calcmode="lin" valueType="num">
                                       <p:cBhvr>
-                                        <p:cTn id="12" dur="400" fill="hold"/>
+                                        <p:cTn id="8" dur="500" fill="hold"/>
                                         <p:tgtEl>
-                                          <p:spTgt spid="17"/>
+                                          <p:spTgt spid="5"/>
                                         </p:tgtEl>
                                         <p:attrNameLst>
                                           <p:attrName>ppt_h</p:attrName>
@@ -13164,37 +12775,64 @@
                                         </p:tav>
                                       </p:tavLst>
                                     </p:anim>
-                                    <p:anim calcmode="lin" valueType="num">
+                                  </p:childTnLst>
+                                </p:cTn>
+                              </p:par>
+                            </p:childTnLst>
+                          </p:cTn>
+                        </p:par>
+                        <p:par>
+                          <p:cTn id="9" fill="hold">
+                            <p:stCondLst>
+                              <p:cond delay="0"/>
+                            </p:stCondLst>
+                            <p:childTnLst>
+                              <p:par>
+                                <p:cTn xmlns:p="http://schemas.openxmlformats.org/presentationml/2006/main" id="10" presetID="8" presetClass="emph" presetSubtype="0" fill="hold" grpId="0" nodeType="withEffect" repeatCount="999000">
+                                  <p:stCondLst>
+                                    <p:cond delay="0"/>
+                                  </p:stCondLst>
+                                  <p:childTnLst>
+                                    <p:animRot by="21600000">
                                       <p:cBhvr>
-                                        <p:cTn id="13" dur="400" fill="hold"/>
+                                        <p:cTn id="11" dur="8000" fill="hold"/>
                                         <p:tgtEl>
                                           <p:spTgt spid="17"/>
                                         </p:tgtEl>
                                         <p:attrNameLst>
-                                          <p:attrName>style.rotation</p:attrName>
+                                          <p:attrName>r</p:attrName>
                                         </p:attrNameLst>
                                       </p:cBhvr>
-                                      <p:tavLst>
-                                        <p:tav tm="0">
-                                          <p:val>
-                                            <p:fltVal val="360"/>
-                                          </p:val>
-                                        </p:tav>
-                                        <p:tav tm="100000">
-                                          <p:val>
-                                            <p:fltVal val="0"/>
-                                          </p:val>
-                                        </p:tav>
-                                      </p:tavLst>
-                                    </p:anim>
-                                    <p:animEffect transition="in" filter="fade">
+                                    </p:animRot>
+                                  </p:childTnLst>
+                                </p:cTn>
+                              </p:par>
+                            </p:childTnLst>
+                          </p:cTn>
+                        </p:par>
+                        <p:par>
+                          <p:cTn id="12" fill="hold">
+                            <p:stCondLst>
+                              <p:cond delay="0"/>
+                            </p:stCondLst>
+                            <p:childTnLst>
+                              <p:par>
+                                <p:cTn xmlns:p="http://schemas.openxmlformats.org/presentationml/2006/main" id="13" presetID="8" presetClass="emph" presetSubtype="0" fill="hold" grpId="0" nodeType="withEffect" repeatCount="999000">
+                                  <p:stCondLst>
+                                    <p:cond delay="0"/>
+                                  </p:stCondLst>
+                                  <p:childTnLst>
+                                    <p:animRot by="21600000">
                                       <p:cBhvr>
-                                        <p:cTn id="14" dur="400"/>
+                                        <p:cTn id="14" dur="12000" fill="hold"/>
                                         <p:tgtEl>
-                                          <p:spTgt spid="17"/>
+                                          <p:spTgt spid="34"/>
                                         </p:tgtEl>
+                                        <p:attrNameLst>
+                                          <p:attrName>r</p:attrName>
+                                        </p:attrNameLst>
                                       </p:cBhvr>
-                                    </p:animEffect>
+                                    </p:animRot>
                                   </p:childTnLst>
                                 </p:cTn>
                               </p:par>
@@ -13204,11 +12842,11 @@
                         <p:par>
                           <p:cTn id="15" fill="hold">
                             <p:stCondLst>
-                              <p:cond delay="1150"/>
+                              <p:cond delay="0"/>
                             </p:stCondLst>
                             <p:childTnLst>
                               <p:par>
-                                <p:cTn xmlns:p="http://schemas.openxmlformats.org/presentationml/2006/main" id="16" presetID="49" presetClass="entr" presetSubtype="0" decel="100000" fill="hold" grpId="0" nodeType="afterEffect">
+                                <p:cTn xmlns:p="http://schemas.openxmlformats.org/presentationml/2006/main" id="16" presetID="23" presetClass="entr" presetSubtype="16" fill="hold" grpId="0" nodeType="afterEffect">
                                   <p:stCondLst>
                                     <p:cond delay="350"/>
                                   </p:stCondLst>
@@ -13216,119 +12854,6 @@
                                     <p:set>
                                       <p:cBhvr>
                                         <p:cTn id="17" dur="1" fill="hold">
-                                          <p:stCondLst>
-                                            <p:cond delay="0"/>
-                                          </p:stCondLst>
-                                        </p:cTn>
-                                        <p:tgtEl>
-                                          <p:spTgt spid="34"/>
-                                        </p:tgtEl>
-                                        <p:attrNameLst>
-                                          <p:attrName>style.visibility</p:attrName>
-                                        </p:attrNameLst>
-                                      </p:cBhvr>
-                                      <p:to>
-                                        <p:strVal val="visible"/>
-                                      </p:to>
-                                    </p:set>
-                                    <p:anim calcmode="lin" valueType="num">
-                                      <p:cBhvr>
-                                        <p:cTn id="18" dur="400" fill="hold"/>
-                                        <p:tgtEl>
-                                          <p:spTgt spid="34"/>
-                                        </p:tgtEl>
-                                        <p:attrNameLst>
-                                          <p:attrName>ppt_w</p:attrName>
-                                        </p:attrNameLst>
-                                      </p:cBhvr>
-                                      <p:tavLst>
-                                        <p:tav tm="0">
-                                          <p:val>
-                                            <p:fltVal val="0"/>
-                                          </p:val>
-                                        </p:tav>
-                                        <p:tav tm="100000">
-                                          <p:val>
-                                            <p:strVal val="#ppt_w"/>
-                                          </p:val>
-                                        </p:tav>
-                                      </p:tavLst>
-                                    </p:anim>
-                                    <p:anim calcmode="lin" valueType="num">
-                                      <p:cBhvr>
-                                        <p:cTn id="19" dur="400" fill="hold"/>
-                                        <p:tgtEl>
-                                          <p:spTgt spid="34"/>
-                                        </p:tgtEl>
-                                        <p:attrNameLst>
-                                          <p:attrName>ppt_h</p:attrName>
-                                        </p:attrNameLst>
-                                      </p:cBhvr>
-                                      <p:tavLst>
-                                        <p:tav tm="0">
-                                          <p:val>
-                                            <p:fltVal val="0"/>
-                                          </p:val>
-                                        </p:tav>
-                                        <p:tav tm="100000">
-                                          <p:val>
-                                            <p:strVal val="#ppt_h"/>
-                                          </p:val>
-                                        </p:tav>
-                                      </p:tavLst>
-                                    </p:anim>
-                                    <p:anim calcmode="lin" valueType="num">
-                                      <p:cBhvr>
-                                        <p:cTn id="20" dur="400" fill="hold"/>
-                                        <p:tgtEl>
-                                          <p:spTgt spid="34"/>
-                                        </p:tgtEl>
-                                        <p:attrNameLst>
-                                          <p:attrName>style.rotation</p:attrName>
-                                        </p:attrNameLst>
-                                      </p:cBhvr>
-                                      <p:tavLst>
-                                        <p:tav tm="0">
-                                          <p:val>
-                                            <p:fltVal val="360"/>
-                                          </p:val>
-                                        </p:tav>
-                                        <p:tav tm="100000">
-                                          <p:val>
-                                            <p:fltVal val="0"/>
-                                          </p:val>
-                                        </p:tav>
-                                      </p:tavLst>
-                                    </p:anim>
-                                    <p:animEffect transition="in" filter="fade">
-                                      <p:cBhvr>
-                                        <p:cTn id="21" dur="400"/>
-                                        <p:tgtEl>
-                                          <p:spTgt spid="34"/>
-                                        </p:tgtEl>
-                                      </p:cBhvr>
-                                    </p:animEffect>
-                                  </p:childTnLst>
-                                </p:cTn>
-                              </p:par>
-                            </p:childTnLst>
-                          </p:cTn>
-                        </p:par>
-                        <p:par>
-                          <p:cTn id="22" fill="hold">
-                            <p:stCondLst>
-                              <p:cond delay="1900"/>
-                            </p:stCondLst>
-                            <p:childTnLst>
-                              <p:par>
-                                <p:cTn xmlns:p="http://schemas.openxmlformats.org/presentationml/2006/main" id="23" presetID="23" presetClass="entr" presetSubtype="16" fill="hold" grpId="0" nodeType="afterEffect">
-                                  <p:stCondLst>
-                                    <p:cond delay="350"/>
-                                  </p:stCondLst>
-                                  <p:childTnLst>
-                                    <p:set>
-                                      <p:cBhvr>
-                                        <p:cTn id="24" dur="1" fill="hold">
                                           <p:stCondLst>
                                             <p:cond delay="0"/>
                                           </p:stCondLst>
@@ -13346,7 +12871,7 @@
                                     </p:set>
                                     <p:anim calcmode="lin" valueType="num">
                                       <p:cBhvr>
-                                        <p:cTn id="25" dur="400" fill="hold"/>
+                                        <p:cTn id="18" dur="500" fill="hold"/>
                                         <p:tgtEl>
                                           <p:spTgt spid="41"/>
                                         </p:tgtEl>
@@ -13369,7 +12894,7 @@
                                     </p:anim>
                                     <p:anim calcmode="lin" valueType="num">
                                       <p:cBhvr>
-                                        <p:cTn id="26" dur="400" fill="hold"/>
+                                        <p:cTn id="19" dur="500" fill="hold"/>
                                         <p:tgtEl>
                                           <p:spTgt spid="41"/>
                                         </p:tgtEl>
@@ -13397,20 +12922,49 @@
                           </p:cTn>
                         </p:par>
                         <p:par>
-                          <p:cTn id="27" fill="hold">
+                          <p:cTn id="20" fill="hold">
                             <p:stCondLst>
-                              <p:cond delay="2650"/>
+                              <p:cond delay="350"/>
                             </p:stCondLst>
                             <p:childTnLst>
                               <p:par>
-                                <p:cTn xmlns:p="http://schemas.openxmlformats.org/presentationml/2006/main" id="28" presetID="9" presetClass="entr" presetSubtype="0" fill="hold" grpId="0" nodeType="afterEffect">
+                                <p:cTn xmlns:p="http://schemas.openxmlformats.org/presentationml/2006/main" id="21" presetID="8" presetClass="emph" presetSubtype="0" fill="hold" grpId="0" nodeType="withEffect" repeatCount="999000">
+                                  <p:stCondLst>
+                                    <p:cond delay="0"/>
+                                  </p:stCondLst>
+                                  <p:childTnLst>
+                                    <p:animRot by="21600000">
+                                      <p:cBhvr>
+                                        <p:cTn id="22" dur="4000" fill="hold"/>
+                                        <p:tgtEl>
+                                          <p:spTgt spid="45"/>
+                                        </p:tgtEl>
+                                        <p:attrNameLst>
+                                          <p:attrName>r</p:attrName>
+                                        </p:attrNameLst>
+                                      </p:cBhvr>
+                                    </p:animRot>
+                                  </p:childTnLst>
+                                </p:cTn>
+                              </p:par>
+                            </p:childTnLst>
+                          </p:cTn>
+                        </p:par>
+                        <p:par>
+                          <p:cTn id="23" fill="hold">
+                            <p:stCondLst>
+                              <p:cond delay="350"/>
+                            </p:stCondLst>
+                            <p:childTnLst>
+                              <p:par>
+                                <p:cTn xmlns:p="http://schemas.openxmlformats.org/presentationml/2006/main" id="24" presetID="6" presetClass="entr" presetSubtype="16" fill="hold" grpId="0" nodeType="afterEffect">
                                   <p:stCondLst>
                                     <p:cond delay="350"/>
                                   </p:stCondLst>
                                   <p:childTnLst>
                                     <p:set>
                                       <p:cBhvr>
-                                        <p:cTn id="29" dur="1" fill="hold">
+                                        <p:cTn id="25" dur="1" fill="hold">
                                           <p:stCondLst>
                                             <p:cond delay="0"/>
                                           </p:stCondLst>
@@ -13426,9 +12980,9 @@
                                         <p:strVal val="visible"/>
                                       </p:to>
                                     </p:set>
-                                    <p:animEffect transition="in" filter="dissolve">
+                                    <p:animEffect transition="in" filter="circle(in)">
                                       <p:cBhvr>
-                                        <p:cTn id="30" dur="400"/>
+                                        <p:cTn id="26" dur="500"/>
                                         <p:tgtEl>
                                           <p:spTgt spid="53"/>
                                         </p:tgtEl>
@@ -13441,20 +12995,49 @@
                           </p:cTn>
                         </p:par>
                         <p:par>
-                          <p:cTn id="31" fill="hold">
+                          <p:cTn id="27" fill="hold">
                             <p:stCondLst>
-                              <p:cond delay="3400"/>
+                              <p:cond delay="700"/>
                             </p:stCondLst>
                             <p:childTnLst>
                               <p:par>
-                                <p:cTn xmlns:p="http://schemas.openxmlformats.org/presentationml/2006/main" id="32" presetID="6" presetClass="entr" presetSubtype="16" fill="hold" grpId="0" nodeType="afterEffect">
+                                <p:cTn xmlns:p="http://schemas.openxmlformats.org/presentationml/2006/main" id="28" presetID="8" presetClass="emph" presetSubtype="0" fill="hold" grpId="0" nodeType="withEffect" repeatCount="999000">
+                                  <p:stCondLst>
+                                    <p:cond delay="0"/>
+                                  </p:stCondLst>
+                                  <p:childTnLst>
+                                    <p:animRot by="21600000">
+                                      <p:cBhvr>
+                                        <p:cTn id="29" dur="4000" fill="hold"/>
+                                        <p:tgtEl>
+                                          <p:spTgt spid="57"/>
+                                        </p:tgtEl>
+                                        <p:attrNameLst>
+                                          <p:attrName>r</p:attrName>
+                                        </p:attrNameLst>
+                                      </p:cBhvr>
+                                    </p:animRot>
+                                  </p:childTnLst>
+                                </p:cTn>
+                              </p:par>
+                            </p:childTnLst>
+                          </p:cTn>
+                        </p:par>
+                        <p:par>
+                          <p:cTn id="30" fill="hold">
+                            <p:stCondLst>
+                              <p:cond delay="700"/>
+                            </p:stCondLst>
+                            <p:childTnLst>
+                              <p:par>
+                                <p:cTn xmlns:p="http://schemas.openxmlformats.org/presentationml/2006/main" id="31" presetID="8" presetClass="entr" presetSubtype="16" fill="hold" grpId="0" nodeType="afterEffect">
                                   <p:stCondLst>
                                     <p:cond delay="350"/>
                                   </p:stCondLst>
                                   <p:childTnLst>
                                     <p:set>
                                       <p:cBhvr>
-                                        <p:cTn id="33" dur="1" fill="hold">
+                                        <p:cTn id="32" dur="1" fill="hold">
                                           <p:stCondLst>
                                             <p:cond delay="0"/>
                                           </p:stCondLst>
@@ -13470,9 +13053,9 @@
                                         <p:strVal val="visible"/>
                                       </p:to>
                                     </p:set>
-                                    <p:animEffect transition="in" filter="circle(in)">
+                                    <p:animEffect transition="in" filter="diamond(in)">
                                       <p:cBhvr>
-                                        <p:cTn id="34" dur="400"/>
+                                        <p:cTn id="33" dur="500"/>
                                         <p:tgtEl>
                                           <p:spTgt spid="65"/>
                                         </p:tgtEl>
@@ -15947,7 +15530,7 @@
   </p:clrMapOvr>
   <mc:AlternateContent xmlns:mc="http://schemas.openxmlformats.org/markup-compatibility/2006">
     <mc:Choice xmlns:p159="http://schemas.microsoft.com/office/powerpoint/2015/09/main" Requires="p159">
-      <p:transition xmlns:p14="http://schemas.microsoft.com/office/powerpoint/2010/main" p14:dur="400">
+      <p:transition xmlns:p14="http://schemas.microsoft.com/office/powerpoint/2010/main" p14:dur="500">
         <p159:morph option="byObject"/>
       </p:transition>
     </mc:Choice>
@@ -16006,7 +15589,7 @@
                                     </p:set>
                                     <p:anim calcmode="lin" valueType="num">
                                       <p:cBhvr>
-                                        <p:cTn id="7" dur="400" fill="hold"/>
+                                        <p:cTn id="7" dur="500" fill="hold"/>
                                         <p:tgtEl>
                                           <p:spTgt spid="5"/>
                                         </p:tgtEl>
@@ -16029,7 +15612,7 @@
                                     </p:anim>
                                     <p:anim calcmode="lin" valueType="num">
                                       <p:cBhvr>
-                                        <p:cTn id="8" dur="400" fill="hold"/>
+                                        <p:cTn id="8" dur="500" fill="hold"/>
                                         <p:tgtEl>
                                           <p:spTgt spid="5"/>
                                         </p:tgtEl>
@@ -16059,110 +15642,26 @@
                         <p:par>
                           <p:cTn id="9" fill="hold">
                             <p:stCondLst>
-                              <p:cond delay="400"/>
+                              <p:cond delay="0"/>
                             </p:stCondLst>
                             <p:childTnLst>
                               <p:par>
-                                <p:cTn xmlns:p="http://schemas.openxmlformats.org/presentationml/2006/main" id="10" presetID="49" presetClass="entr" presetSubtype="0" decel="100000" fill="hold" grpId="0" nodeType="afterEffect">
+                                <p:cTn xmlns:p="http://schemas.openxmlformats.org/presentationml/2006/main" id="10" presetID="8" presetClass="emph" presetSubtype="0" fill="hold" grpId="0" nodeType="withEffect" repeatCount="999000">
                                   <p:stCondLst>
-                                    <p:cond delay="350"/>
+                                    <p:cond delay="0"/>
                                   </p:stCondLst>
                                   <p:childTnLst>
-                                    <p:set>
+                                    <p:animRot by="21600000">
                                       <p:cBhvr>
-                                        <p:cTn id="11" dur="1" fill="hold">
-                                          <p:stCondLst>
-                                            <p:cond delay="0"/>
-                                          </p:stCondLst>
-                                        </p:cTn>
+                                        <p:cTn id="11" dur="8000" fill="hold"/>
                                         <p:tgtEl>
                                           <p:spTgt spid="17"/>
                                         </p:tgtEl>
                                         <p:attrNameLst>
-                                          <p:attrName>style.visibility</p:attrName>
+                                          <p:attrName>r</p:attrName>
                                         </p:attrNameLst>
                                       </p:cBhvr>
-                                      <p:to>
-                                        <p:strVal val="visible"/>
-                                      </p:to>
-                                    </p:set>
-                                    <p:anim calcmode="lin" valueType="num">
-                                      <p:cBhvr>
-                                        <p:cTn id="12" dur="400" fill="hold"/>
-                                        <p:tgtEl>
-                                          <p:spTgt spid="17"/>
-                                        </p:tgtEl>
-                                        <p:attrNameLst>
-                                          <p:attrName>ppt_w</p:attrName>
-                                        </p:attrNameLst>
-                                      </p:cBhvr>
-                                      <p:tavLst>
-                                        <p:tav tm="0">
-                                          <p:val>
-                                            <p:fltVal val="0"/>
-                                          </p:val>
-                                        </p:tav>
-                                        <p:tav tm="100000">
-                                          <p:val>
-                                            <p:strVal val="#ppt_w"/>
-                                          </p:val>
-                                        </p:tav>
-                                      </p:tavLst>
-                                    </p:anim>
-                                    <p:anim calcmode="lin" valueType="num">
-                                      <p:cBhvr>
-                                        <p:cTn id="13" dur="400" fill="hold"/>
-                                        <p:tgtEl>
-                                          <p:spTgt spid="17"/>
-                                        </p:tgtEl>
-                                        <p:attrNameLst>
-                                          <p:attrName>ppt_h</p:attrName>
-                                        </p:attrNameLst>
-                                      </p:cBhvr>
-                                      <p:tavLst>
-                                        <p:tav tm="0">
-                                          <p:val>
-                                            <p:fltVal val="0"/>
-                                          </p:val>
-                                        </p:tav>
-                                        <p:tav tm="100000">
-                                          <p:val>
-                                            <p:strVal val="#ppt_h"/>
-                                          </p:val>
-                                        </p:tav>
-                                      </p:tavLst>
-                                    </p:anim>
-                                    <p:anim calcmode="lin" valueType="num">
-                                      <p:cBhvr>
-                                        <p:cTn id="14" dur="400" fill="hold"/>
-                                        <p:tgtEl>
-                                          <p:spTgt spid="17"/>
-                                        </p:tgtEl>
-                                        <p:attrNameLst>
-                                          <p:attrName>style.rotation</p:attrName>
-                                        </p:attrNameLst>
-                                      </p:cBhvr>
-                                      <p:tavLst>
-                                        <p:tav tm="0">
-                                          <p:val>
-                                            <p:fltVal val="360"/>
-                                          </p:val>
-                                        </p:tav>
-                                        <p:tav tm="100000">
-                                          <p:val>
-                                            <p:fltVal val="0"/>
-                                          </p:val>
-                                        </p:tav>
-                                      </p:tavLst>
-                                    </p:anim>
-                                    <p:animEffect transition="in" filter="fade">
-                                      <p:cBhvr>
-                                        <p:cTn id="15" dur="400"/>
-                                        <p:tgtEl>
-                                          <p:spTgt spid="17"/>
-                                        </p:tgtEl>
-                                      </p:cBhvr>
-                                    </p:animEffect>
+                                    </p:animRot>
                                   </p:childTnLst>
                                 </p:cTn>
                               </p:par>
@@ -16170,112 +15669,28 @@
                           </p:cTn>
                         </p:par>
                         <p:par>
-                          <p:cTn id="16" fill="hold">
+                          <p:cTn id="12" fill="hold">
                             <p:stCondLst>
-                              <p:cond delay="1150"/>
+                              <p:cond delay="0"/>
                             </p:stCondLst>
                             <p:childTnLst>
                               <p:par>
-                                <p:cTn xmlns:p="http://schemas.openxmlformats.org/presentationml/2006/main" id="17" presetID="49" presetClass="entr" presetSubtype="0" decel="100000" fill="hold" grpId="0" nodeType="afterEffect">
+                                <p:cTn xmlns:p="http://schemas.openxmlformats.org/presentationml/2006/main" id="13" presetID="8" presetClass="emph" presetSubtype="0" fill="hold" grpId="0" nodeType="withEffect" repeatCount="999000">
                                   <p:stCondLst>
-                                    <p:cond delay="350"/>
+                                    <p:cond delay="0"/>
                                   </p:stCondLst>
                                   <p:childTnLst>
-                                    <p:set>
+                                    <p:animRot by="21600000">
                                       <p:cBhvr>
-                                        <p:cTn id="18" dur="1" fill="hold">
-                                          <p:stCondLst>
-                                            <p:cond delay="0"/>
-                                          </p:stCondLst>
-                                        </p:cTn>
+                                        <p:cTn id="14" dur="12000" fill="hold"/>
                                         <p:tgtEl>
                                           <p:spTgt spid="34"/>
                                         </p:tgtEl>
                                         <p:attrNameLst>
-                                          <p:attrName>style.visibility</p:attrName>
+                                          <p:attrName>r</p:attrName>
                                         </p:attrNameLst>
                                       </p:cBhvr>
-                                      <p:to>
-                                        <p:strVal val="visible"/>
-                                      </p:to>
-                                    </p:set>
-                                    <p:anim calcmode="lin" valueType="num">
-                                      <p:cBhvr>
-                                        <p:cTn id="19" dur="400" fill="hold"/>
-                                        <p:tgtEl>
-                                          <p:spTgt spid="34"/>
-                                        </p:tgtEl>
-                                        <p:attrNameLst>
-                                          <p:attrName>ppt_w</p:attrName>
-                                        </p:attrNameLst>
-                                      </p:cBhvr>
-                                      <p:tavLst>
-                                        <p:tav tm="0">
-                                          <p:val>
-                                            <p:fltVal val="0"/>
-                                          </p:val>
-                                        </p:tav>
-                                        <p:tav tm="100000">
-                                          <p:val>
-                                            <p:strVal val="#ppt_w"/>
-                                          </p:val>
-                                        </p:tav>
-                                      </p:tavLst>
-                                    </p:anim>
-                                    <p:anim calcmode="lin" valueType="num">
-                                      <p:cBhvr>
-                                        <p:cTn id="20" dur="400" fill="hold"/>
-                                        <p:tgtEl>
-                                          <p:spTgt spid="34"/>
-                                        </p:tgtEl>
-                                        <p:attrNameLst>
-                                          <p:attrName>ppt_h</p:attrName>
-                                        </p:attrNameLst>
-                                      </p:cBhvr>
-                                      <p:tavLst>
-                                        <p:tav tm="0">
-                                          <p:val>
-                                            <p:fltVal val="0"/>
-                                          </p:val>
-                                        </p:tav>
-                                        <p:tav tm="100000">
-                                          <p:val>
-                                            <p:strVal val="#ppt_h"/>
-                                          </p:val>
-                                        </p:tav>
-                                      </p:tavLst>
-                                    </p:anim>
-                                    <p:anim calcmode="lin" valueType="num">
-                                      <p:cBhvr>
-                                        <p:cTn id="21" dur="400" fill="hold"/>
-                                        <p:tgtEl>
-                                          <p:spTgt spid="34"/>
-                                        </p:tgtEl>
-                                        <p:attrNameLst>
-                                          <p:attrName>style.rotation</p:attrName>
-                                        </p:attrNameLst>
-                                      </p:cBhvr>
-                                      <p:tavLst>
-                                        <p:tav tm="0">
-                                          <p:val>
-                                            <p:fltVal val="360"/>
-                                          </p:val>
-                                        </p:tav>
-                                        <p:tav tm="100000">
-                                          <p:val>
-                                            <p:fltVal val="0"/>
-                                          </p:val>
-                                        </p:tav>
-                                      </p:tavLst>
-                                    </p:anim>
-                                    <p:animEffect transition="in" filter="fade">
-                                      <p:cBhvr>
-                                        <p:cTn id="22" dur="400"/>
-                                        <p:tgtEl>
-                                          <p:spTgt spid="34"/>
-                                        </p:tgtEl>
-                                      </p:cBhvr>
-                                    </p:animEffect>
+                                    </p:animRot>
                                   </p:childTnLst>
                                 </p:cTn>
                               </p:par>
@@ -16283,20 +15698,20 @@
                           </p:cTn>
                         </p:par>
                         <p:par>
-                          <p:cTn id="23" fill="hold">
+                          <p:cTn id="15" fill="hold">
                             <p:stCondLst>
-                              <p:cond delay="1900"/>
+                              <p:cond delay="0"/>
                             </p:stCondLst>
                             <p:childTnLst>
                               <p:par>
-                                <p:cTn xmlns:p="http://schemas.openxmlformats.org/presentationml/2006/main" id="24" presetID="2" presetClass="entr" presetSubtype="4" fill="hold" grpId="0" nodeType="afterEffect">
+                                <p:cTn xmlns:p="http://schemas.openxmlformats.org/presentationml/2006/main" id="16" presetID="2" presetClass="entr" presetSubtype="4" fill="hold" grpId="0" nodeType="afterEffect">
                                   <p:stCondLst>
                                     <p:cond delay="350"/>
                                   </p:stCondLst>
                                   <p:childTnLst>
                                     <p:set>
                                       <p:cBhvr>
-                                        <p:cTn id="25" dur="1" fill="hold">
+                                        <p:cTn id="17" dur="1" fill="hold">
                                           <p:stCondLst>
                                             <p:cond delay="0"/>
                                           </p:stCondLst>
@@ -16314,7 +15729,7 @@
                                     </p:set>
                                     <p:anim calcmode="lin" valueType="num">
                                       <p:cBhvr additive="base">
-                                        <p:cTn id="26" dur="400" fill="hold"/>
+                                        <p:cTn id="18" dur="500" fill="hold"/>
                                         <p:tgtEl>
                                           <p:spTgt spid="56"/>
                                         </p:tgtEl>
@@ -16337,7 +15752,7 @@
                                     </p:anim>
                                     <p:anim calcmode="lin" valueType="num">
                                       <p:cBhvr additive="base">
-                                        <p:cTn id="27" dur="400" fill="hold"/>
+                                        <p:cTn id="19" dur="500" fill="hold"/>
                                         <p:tgtEl>
                                           <p:spTgt spid="56"/>
                                         </p:tgtEl>
@@ -16365,20 +15780,20 @@
                           </p:cTn>
                         </p:par>
                         <p:par>
-                          <p:cTn id="28" fill="hold">
+                          <p:cTn id="20" fill="hold">
                             <p:stCondLst>
-                              <p:cond delay="2650"/>
+                              <p:cond delay="850"/>
                             </p:stCondLst>
                             <p:childTnLst>
                               <p:par>
-                                <p:cTn xmlns:p="http://schemas.openxmlformats.org/presentationml/2006/main" id="29" presetID="23" presetClass="entr" presetSubtype="16" fill="hold" grpId="0" nodeType="afterEffect">
+                                <p:cTn xmlns:p="http://schemas.openxmlformats.org/presentationml/2006/main" id="21" presetID="23" presetClass="entr" presetSubtype="16" fill="hold" grpId="0" nodeType="afterEffect">
                                   <p:stCondLst>
                                     <p:cond delay="350"/>
                                   </p:stCondLst>
                                   <p:childTnLst>
                                     <p:set>
                                       <p:cBhvr>
-                                        <p:cTn id="30" dur="1" fill="hold">
+                                        <p:cTn id="22" dur="1" fill="hold">
                                           <p:stCondLst>
                                             <p:cond delay="0"/>
                                           </p:stCondLst>
@@ -16396,7 +15811,7 @@
                                     </p:set>
                                     <p:anim calcmode="lin" valueType="num">
                                       <p:cBhvr>
-                                        <p:cTn id="31" dur="400" fill="hold"/>
+                                        <p:cTn id="23" dur="500" fill="hold"/>
                                         <p:tgtEl>
                                           <p:spTgt spid="73"/>
                                         </p:tgtEl>
@@ -16419,7 +15834,7 @@
                                     </p:anim>
                                     <p:anim calcmode="lin" valueType="num">
                                       <p:cBhvr>
-                                        <p:cTn id="32" dur="400" fill="hold"/>
+                                        <p:cTn id="24" dur="500" fill="hold"/>
                                         <p:tgtEl>
                                           <p:spTgt spid="73"/>
                                         </p:tgtEl>
@@ -16447,112 +15862,28 @@
                           </p:cTn>
                         </p:par>
                         <p:par>
-                          <p:cTn id="33" fill="hold">
+                          <p:cTn id="25" fill="hold">
                             <p:stCondLst>
-                              <p:cond delay="3400"/>
+                              <p:cond delay="1200"/>
                             </p:stCondLst>
                             <p:childTnLst>
                               <p:par>
-                                <p:cTn xmlns:p="http://schemas.openxmlformats.org/presentationml/2006/main" id="34" presetID="49" presetClass="entr" presetSubtype="0" decel="100000" fill="hold" grpId="0" nodeType="afterEffect">
+                                <p:cTn xmlns:p="http://schemas.openxmlformats.org/presentationml/2006/main" id="26" presetID="8" presetClass="emph" presetSubtype="0" fill="hold" grpId="0" nodeType="withEffect" repeatCount="999000">
                                   <p:stCondLst>
-                                    <p:cond delay="350"/>
+                                    <p:cond delay="0"/>
                                   </p:stCondLst>
                                   <p:childTnLst>
-                                    <p:set>
+                                    <p:animRot by="21600000">
                                       <p:cBhvr>
-                                        <p:cTn id="35" dur="1" fill="hold">
-                                          <p:stCondLst>
-                                            <p:cond delay="0"/>
-                                          </p:stCondLst>
-                                        </p:cTn>
+                                        <p:cTn id="27" dur="4000" fill="hold"/>
                                         <p:tgtEl>
                                           <p:spTgt spid="80"/>
                                         </p:tgtEl>
                                         <p:attrNameLst>
-                                          <p:attrName>style.visibility</p:attrName>
+                                          <p:attrName>r</p:attrName>
                                         </p:attrNameLst>
                                       </p:cBhvr>
-                                      <p:to>
-                                        <p:strVal val="visible"/>
-                                      </p:to>
-                                    </p:set>
-                                    <p:anim calcmode="lin" valueType="num">
-                                      <p:cBhvr>
-                                        <p:cTn id="36" dur="400" fill="hold"/>
-                                        <p:tgtEl>
-                                          <p:spTgt spid="80"/>
-                                        </p:tgtEl>
-                                        <p:attrNameLst>
-                                          <p:attrName>ppt_w</p:attrName>
-                                        </p:attrNameLst>
-                                      </p:cBhvr>
-                                      <p:tavLst>
-                                        <p:tav tm="0">
-                                          <p:val>
-                                            <p:fltVal val="0"/>
-                                          </p:val>
-                                        </p:tav>
-                                        <p:tav tm="100000">
-                                          <p:val>
-                                            <p:strVal val="#ppt_w"/>
-                                          </p:val>
-                                        </p:tav>
-                                      </p:tavLst>
-                                    </p:anim>
-                                    <p:anim calcmode="lin" valueType="num">
-                                      <p:cBhvr>
-                                        <p:cTn id="37" dur="400" fill="hold"/>
-                                        <p:tgtEl>
-                                          <p:spTgt spid="80"/>
-                                        </p:tgtEl>
-                                        <p:attrNameLst>
-                                          <p:attrName>ppt_h</p:attrName>
-                                        </p:attrNameLst>
-                                      </p:cBhvr>
-                                      <p:tavLst>
-                                        <p:tav tm="0">
-                                          <p:val>
-                                            <p:fltVal val="0"/>
-                                          </p:val>
-                                        </p:tav>
-                                        <p:tav tm="100000">
-                                          <p:val>
-                                            <p:strVal val="#ppt_h"/>
-                                          </p:val>
-                                        </p:tav>
-                                      </p:tavLst>
-                                    </p:anim>
-                                    <p:anim calcmode="lin" valueType="num">
-                                      <p:cBhvr>
-                                        <p:cTn id="38" dur="400" fill="hold"/>
-                                        <p:tgtEl>
-                                          <p:spTgt spid="80"/>
-                                        </p:tgtEl>
-                                        <p:attrNameLst>
-                                          <p:attrName>style.rotation</p:attrName>
-                                        </p:attrNameLst>
-                                      </p:cBhvr>
-                                      <p:tavLst>
-                                        <p:tav tm="0">
-                                          <p:val>
-                                            <p:fltVal val="360"/>
-                                          </p:val>
-                                        </p:tav>
-                                        <p:tav tm="100000">
-                                          <p:val>
-                                            <p:fltVal val="0"/>
-                                          </p:val>
-                                        </p:tav>
-                                      </p:tavLst>
-                                    </p:anim>
-                                    <p:animEffect transition="in" filter="fade">
-                                      <p:cBhvr>
-                                        <p:cTn id="39" dur="400"/>
-                                        <p:tgtEl>
-                                          <p:spTgt spid="80"/>
-                                        </p:tgtEl>
-                                      </p:cBhvr>
-                                    </p:animEffect>
+                                    </p:animRot>
                                   </p:childTnLst>
                                 </p:cTn>
                               </p:par>

</xml_diff>